<commit_message>
Vortrag 4: Belege nach APA 7, Chi-Quadrat-Test entfernt, Überarbeitung
- Notebook, Ausarbeitung und Folien mit Kurzbelegen (Seiten- bzw. Foliennummern)
  und Literaturverzeichnis nach APA 7
- Chi-Quadrat-Test entfernt; Unabhängigkeit nur über die Definition aus dem
  Folienskript beurteilt
- Begriffe aus dem Kurs übernommen (Säulendiagramm, Kreuztabelle)
- Abbildungen und Tabellen im APA-Format, Differenzen aus exakten Anzahlen

Co-Authored-By: Claude Opus 5.5 <noreply@anthropic.com>
Claude-Session: https://claude.ai/code/session_013vrRC9ggswsEWMp2ebeFzZ
</commit_message>
<xml_diff>
--- a/vortrag4/Vortrag4_Praesentation.pptx
+++ b/vortrag4/Vortrag4_Praesentation.pptx
@@ -583,7 +583,7 @@
           <a:lstStyle/>
           <a:p>
             <a:r>
-              <a:t>Definition aus Teil 3: P(A|B) = P(A) bzw. P(A∩B) = P(A)P(B). Gesamt: 0.1231 statt 0.1572, also abhängig, Chi2 = 92.2, p &lt; 0.001. Je Fachbereich: B bis F unabhängig (p &gt; 0.3), nur A abhängig, aber zugunsten der Frauen. Bedingte Unabhängigkeit gegeben Fachbereich; der Fachbereich ist der Confounder.</a:t>
+              <a:t>Definition aus Teil 3, Folie 34: P(A|B) = P(A) bzw. P(A∩B) = P(A)·P(B), wie im Beispiel Navi und Klimaanlage. Gesamt: P(Z∩W) = 0.1231 statt 0.1572, also abhängig. Je Fachbereich: B bis F höchstens 5 Prozentpunkte Unterschied mit wechselnder Richtung, also annähernd unabhängig; B beruht auf nur 25 Frauen. Nur A deutlich abhängig, aber zugunsten der Frauen. Der Fachbereich ist die Drittvariable.</a:t>
             </a:r>
           </a:p>
         </p:txBody>
@@ -653,7 +653,7 @@
           <a:lstStyle/>
           <a:p>
             <a:r>
-              <a:t>Die Zusammenfassung verbirgt die Drittvariable Fachbereich: Simpson-Paradoxon. Keine Benachteiligung durch die Fachbereiche nachweisbar, aber offene Frage, warum Frauen sich in selektivere Fachbereiche bewarben. Programmtechnisch: Funktionen machen die Analyse wiederverwendbar.</a:t>
+              <a:t>Die Zusammenfassung verbirgt die Drittvariable Fachbereich: Simpson-Paradoxon (Simpson, 1951). Eine Benachteiligung durch die Fachbereiche ist nicht erkennbar; offen bleibt, warum Frauen sich in selektivere Fachbereiche bewarben. Ob kleine Abweichungen zufällig sind, würde ein Hypothesentest klären; der ist erst später im Semester dran. Programmtechnisch: Funktionen machen die Analyse wiederverwendbar.</a:t>
             </a:r>
           </a:p>
         </p:txBody>
@@ -793,7 +793,7 @@
           <a:lstStyle/>
           <a:p>
             <a:r>
-              <a:t>1973 befürchtete die UC Berkeley eine Klage: aggregiert wurden deutlich weniger Frauen zugelassen. Unsere drei Aufgaben: (a) Funktionen in Python, (b) Darstellung der scheinbaren Ungerechtigkeit, (c) Vergleich der Verteilungen und stochastische Unabhängigkeit.</a:t>
+              <a:t>4 526 Bewerbungen an den sechs grössten Fachbereichen. Aggregiert wurden deutlich weniger Frauen zugelassen; Bickel et al. (1975) haben die Zahlen auf eine Benachteiligung von Frauen untersucht. Unsere drei Aufgaben: (a) Funktionen in Python, (b) Darstellung der scheinbaren Ungerechtigkeit, (c) Vergleich der Verteilungen und stochastische Unabhängigkeit.</a:t>
             </a:r>
           </a:p>
         </p:txBody>
@@ -863,7 +863,7 @@
           <a:lstStyle/>
           <a:p>
             <a:r>
-              <a:t>Faustregel McKinney: Code, den man mehr als einmal braucht, gehört in eine Funktion. def/return, Positions- vs. Keyword-Argumente (Keyword nach Position, Reihenfolge egal). Lokaler Namensraum wird beim Aufruf erzeugt und danach zerstört; global möglichst vermeiden. Mehrere Rückgabewerte sind eigentlich ein Tupel; Alternative Dictionary. Rechts: unsere Anwendung.</a:t>
+              <a:t>Faustregel McKinney: Code, den man mehr als einmal braucht, gehört in eine Funktion (S. 71). def/return, Positions- vs. Keyword-Argumente: Keyword nach Position, untereinander Reihenfolge egal (S. 72). Lokaler Namensraum wird beim Aufruf erzeugt und danach gelöscht; global möglichst vermeiden (S. 72–73). Mehrere Rückgabewerte sind eigentlich ein Tupel; Alternative Dictionary (S. 73–74). Rechts: unsere Anwendung.</a:t>
             </a:r>
           </a:p>
         </p:txBody>
@@ -933,7 +933,7 @@
           <a:lstStyle/>
           <a:p>
             <a:r>
-              <a:t>Funktionen lassen sich in Listen speichern und als Argument übergeben (Muster clean_strings aus McKinney). Lambda: anonyme Einzeiler, ideal als Argument. partial: Currying. yield: Generator mit Lazy Evaluation. try/except: nur erwartete Fehler (ValueError) abfangen.</a:t>
+              <a:t>Funktionen lassen sich in Listen speichern und als Argument übergeben, Muster clean_strings (S. 74–75). Lambda: anonyme Einzeiler, ideal als Argument (S. 75–76). partial: Currying (S. 76–77). yield: Generator mit Lazy Evaluation (S. 77–78). try/except: nur den erwarteten Fehler (ValueError) abfangen (S. 79–81).</a:t>
             </a:r>
           </a:p>
         </p:txBody>
@@ -1003,7 +1003,7 @@
           <a:lstStyle/>
           <a:p>
             <a:r>
-              <a:t>Tabelle 4 hat nur Prozente. Für P(W) und Chi-Quadrat brauchen wir Anzahlen: aus Originaldatensatz, Code prüft Übereinstimmung mit Tabelle 4 (0 Abweichungen). Plausibilisierung: Satz der totalen Wahrscheinlichkeit reproduziert die Totalzeile. Libraries: pandas, numpy, matplotlib, scipy; alle in Anaconda.</a:t>
+              <a:t>Tabelle 4 hat nur Prozente. Für P(W) und P(Z ∩ W) brauchen wir Anzahlen: aus dem Originaldatensatz (R-Datensatz UCBAdmissions), der Code prüft die Übereinstimmung mit Tabelle 4 (0 Abweichungen). Plausibilisierung: Der Satz der totalen Wahrscheinlichkeit reproduziert die Zeile Total. Diagrammtypen wie im Folienskript Teil 1. Libraries: pandas, numpy, matplotlib; alle in Anaconda enthalten.</a:t>
             </a:r>
           </a:p>
         </p:txBody>
@@ -1073,7 +1073,7 @@
           <a:lstStyle/>
           <a:p>
             <a:r>
-              <a:t>Ein einziger Vergleich genügt: Gesamtquote. Balken mit Nullachse, Werte direkt beschriftet, Differenz eingezeichnet. 44.5 vs. 30.4 Prozent, 14.2 Prozentpunkte. Bei der Quote der Männer wären 817 statt 557 Frauen zugelassen worden.</a:t>
+              <a:t>Ein einziger Vergleich genügt: die Gesamtquote. Säulendiagramm mit Nullachse, Werte direkt beschriftet, Differenz eingezeichnet. 44.5 vs. 30.4 Prozent, also 14.2 Prozentpunkte. Bei der Quote der Männer wären 817 statt 557 Frauen zugelassen worden.</a:t>
             </a:r>
           </a:p>
         </p:txBody>
@@ -1143,7 +1143,7 @@
           <a:lstStyle/>
           <a:p>
             <a:r>
-              <a:t>Wendepunkt: In 4 von 6 Fachbereichen haben Frauen die höhere Quote, in A sogar +20 Prozentpunkte. Nur in C und E leicht tiefer (−2.8, −3.8).</a:t>
+              <a:t>Wendepunkt: In 4 von 6 Fachbereichen haben Frauen die höhere Quote, in A sogar +20.3 Prozentpunkte. Nur in C und E liegen sie leicht tiefer (−2.9 und −3.8 Prozentpunkte).</a:t>
             </a:r>
           </a:p>
         </p:txBody>
@@ -1213,7 +1213,7 @@
           <a:lstStyle/>
           <a:p>
             <a:r>
-              <a:t>51.5 % der Männer in A oder B (Quote ca. 64 %), nur 7.2 % der Frauen. 92.8 % der Frauen in C bis F mit Quoten 6 bis 35 %. Korrelation Frauenanteil zu Zulassungsquote r = −0.79.</a:t>
+              <a:t>51.5 % der Männer bewarben sich in A oder B (Quote ca. 64 %), aber nur 7.2 % der Frauen. 92.8 % der Frauen bewarben sich in C bis F mit Quoten von 6 bis 35 %. Korrelation Frauenanteil zu Zulassungsquote: r = −0.79.</a:t>
             </a:r>
           </a:p>
         </p:txBody>
@@ -1283,7 +1283,7 @@
           <a:lstStyle/>
           <a:p>
             <a:r>
-              <a:t>Gesamtquote = gewichteter Mittelwert. Frauen haben hohe Gewichte bei tiefen Quoten. Gleiche Gewichte für beide (Verteilung aller Bewerbungen): Frauen 43.0 %, Männer 38.7 %. Der Unterschied kehrt sich um. Technisch: dieselbe Funktion gesamtquote, nur andere Gewichte.</a:t>
+              <a:t>Im Baumdiagramm: alle Wege nach B addieren (Folienskript Teil 3, Folie 37). Die Gesamtquote ist ein gewichteter Mittelwert der Fachbereichsquoten. Frauen haben hohe Gewichte bei tiefen Quoten. Mit gleichen Gewichten für beide (Verteilung aller Bewerbungen): Frauen 43.0 %, Männer 38.7 %. Der Unterschied kehrt sich um. Technisch: dieselbe Funktion gesamtquote, nur andere Gewichte.</a:t>
             </a:r>
           </a:p>
         </p:txBody>
@@ -4668,8 +4668,8 @@
           <p:nvPr/>
         </p:nvGraphicFramePr>
         <p:xfrm>
-          <a:off x="540000" y="1908000"/>
-          <a:ext cx="11160000" cy="3600000"/>
+          <a:off x="540000" y="1872000"/>
+          <a:ext cx="11159999" cy="3600000"/>
         </p:xfrm>
         <a:graphic>
           <a:graphicData uri="http://schemas.openxmlformats.org/drawingml/2006/table">
@@ -4678,12 +4678,13 @@
                 <a:tableStyleId>{5C22544A-7EE6-4342-B048-85BDC9FD1C3A}</a:tableStyleId>
               </a:tblPr>
               <a:tblGrid>
-                <a:gridCol w="1080000"/>
-                <a:gridCol w="1422000"/>
-                <a:gridCol w="1422000"/>
-                <a:gridCol w="1422000"/>
-                <a:gridCol w="1422000"/>
-                <a:gridCol w="4392000"/>
+                <a:gridCol w="1007999"/>
+                <a:gridCol w="1152000"/>
+                <a:gridCol w="1152000"/>
+                <a:gridCol w="1296000"/>
+                <a:gridCol w="1152000"/>
+                <a:gridCol w="1296000"/>
+                <a:gridCol w="4104000"/>
               </a:tblGrid>
               <a:tr h="450000">
                 <a:tc>
@@ -4727,6 +4728,19 @@
                     <a:p>
                       <a:r>
                         <a:rPr sz="1500" b="1"/>
+                        <a:t>Differenz</a:t>
+                      </a:r>
+                    </a:p>
+                  </a:txBody>
+                  <a:tcPr/>
+                </a:tc>
+                <a:tc>
+                  <a:txBody>
+                    <a:bodyPr/>
+                    <a:lstStyle/>
+                    <a:p>
+                      <a:r>
+                        <a:rPr sz="1500" b="1"/>
                         <a:t>P(Z∩W)</a:t>
                       </a:r>
                     </a:p>
@@ -4753,7 +4767,7 @@
                     <a:p>
                       <a:r>
                         <a:rPr sz="1500" b="1"/>
-                        <a:t>Chi-Quadrat-Test (α = 5 %)</a:t>
+                        <a:t>Beurteilung</a:t>
                       </a:r>
                     </a:p>
                   </a:txBody>
@@ -4807,6 +4821,19 @@
                     <a:p>
                       <a:r>
                         <a:rPr sz="1500" b="1"/>
+                        <a:t>−14.2 PP</a:t>
+                      </a:r>
+                    </a:p>
+                  </a:txBody>
+                  <a:tcPr/>
+                </a:tc>
+                <a:tc>
+                  <a:txBody>
+                    <a:bodyPr/>
+                    <a:lstStyle/>
+                    <a:p>
+                      <a:r>
+                        <a:rPr sz="1500" b="1"/>
                         <a:t>0.1231</a:t>
                       </a:r>
                     </a:p>
@@ -4833,7 +4860,7 @@
                     <a:p>
                       <a:r>
                         <a:rPr sz="1500" b="1"/>
-                        <a:t>χ² = 92.2, p &lt; 0.001: abhängig</a:t>
+                        <a:t>abhängig</a:t>
                       </a:r>
                     </a:p>
                   </a:txBody>
@@ -4887,6 +4914,19 @@
                     <a:p>
                       <a:r>
                         <a:rPr sz="1500" b="0"/>
+                        <a:t>+20.3 PP</a:t>
+                      </a:r>
+                    </a:p>
+                  </a:txBody>
+                  <a:tcPr/>
+                </a:tc>
+                <a:tc>
+                  <a:txBody>
+                    <a:bodyPr/>
+                    <a:lstStyle/>
+                    <a:p>
+                      <a:r>
+                        <a:rPr sz="1500" b="0"/>
                         <a:t>0.0954</a:t>
                       </a:r>
                     </a:p>
@@ -4913,7 +4953,7 @@
                     <a:p>
                       <a:r>
                         <a:rPr sz="1500" b="0"/>
-                        <a:t>χ² = 17.3, p &lt; 0.001: abhängig (pro Frauen)</a:t>
+                        <a:t>abhängig, zugunsten Frauen</a:t>
                       </a:r>
                     </a:p>
                   </a:txBody>
@@ -4967,6 +5007,19 @@
                     <a:p>
                       <a:r>
                         <a:rPr sz="1500" b="0"/>
+                        <a:t>+5.0 PP</a:t>
+                      </a:r>
+                    </a:p>
+                  </a:txBody>
+                  <a:tcPr/>
+                </a:tc>
+                <a:tc>
+                  <a:txBody>
+                    <a:bodyPr/>
+                    <a:lstStyle/>
+                    <a:p>
+                      <a:r>
+                        <a:rPr sz="1500" b="0"/>
                         <a:t>0.0291</a:t>
                       </a:r>
                     </a:p>
@@ -4993,7 +5046,7 @@
                     <a:p>
                       <a:r>
                         <a:rPr sz="1500" b="0"/>
-                        <a:t>p = 0.61: unabhängig</a:t>
+                        <a:t>annähernd unabhängig (nur 25 Frauen)</a:t>
                       </a:r>
                     </a:p>
                   </a:txBody>
@@ -5047,6 +5100,19 @@
                     <a:p>
                       <a:r>
                         <a:rPr sz="1500" b="0"/>
+                        <a:t>−2.9 PP</a:t>
+                      </a:r>
+                    </a:p>
+                  </a:txBody>
+                  <a:tcPr/>
+                </a:tc>
+                <a:tc>
+                  <a:txBody>
+                    <a:bodyPr/>
+                    <a:lstStyle/>
+                    <a:p>
+                      <a:r>
+                        <a:rPr sz="1500" b="0"/>
                         <a:t>0.2200</a:t>
                       </a:r>
                     </a:p>
@@ -5073,7 +5139,7 @@
                     <a:p>
                       <a:r>
                         <a:rPr sz="1500" b="0"/>
-                        <a:t>p = 0.39: unabhängig</a:t>
+                        <a:t>annähernd unabhängig</a:t>
                       </a:r>
                     </a:p>
                   </a:txBody>
@@ -5127,6 +5193,19 @@
                     <a:p>
                       <a:r>
                         <a:rPr sz="1500" b="0"/>
+                        <a:t>+1.8 PP</a:t>
+                      </a:r>
+                    </a:p>
+                  </a:txBody>
+                  <a:tcPr/>
+                </a:tc>
+                <a:tc>
+                  <a:txBody>
+                    <a:bodyPr/>
+                    <a:lstStyle/>
+                    <a:p>
+                      <a:r>
+                        <a:rPr sz="1500" b="0"/>
                         <a:t>0.1654</a:t>
                       </a:r>
                     </a:p>
@@ -5153,7 +5232,7 @@
                     <a:p>
                       <a:r>
                         <a:rPr sz="1500" b="0"/>
-                        <a:t>p = 0.59: unabhängig</a:t>
+                        <a:t>annähernd unabhängig</a:t>
                       </a:r>
                     </a:p>
                   </a:txBody>
@@ -5207,6 +5286,19 @@
                     <a:p>
                       <a:r>
                         <a:rPr sz="1500" b="0"/>
+                        <a:t>−3.8 PP</a:t>
+                      </a:r>
+                    </a:p>
+                  </a:txBody>
+                  <a:tcPr/>
+                </a:tc>
+                <a:tc>
+                  <a:txBody>
+                    <a:bodyPr/>
+                    <a:lstStyle/>
+                    <a:p>
+                      <a:r>
+                        <a:rPr sz="1500" b="0"/>
                         <a:t>0.1610</a:t>
                       </a:r>
                     </a:p>
@@ -5233,7 +5325,7 @@
                     <a:p>
                       <a:r>
                         <a:rPr sz="1500" b="0"/>
-                        <a:t>p = 0.32: unabhängig</a:t>
+                        <a:t>annähernd unabhängig</a:t>
                       </a:r>
                     </a:p>
                   </a:txBody>
@@ -5287,6 +5379,19 @@
                     <a:p>
                       <a:r>
                         <a:rPr sz="1500" b="0"/>
+                        <a:t>+1.1 PP</a:t>
+                      </a:r>
+                    </a:p>
+                  </a:txBody>
+                  <a:tcPr/>
+                </a:tc>
+                <a:tc>
+                  <a:txBody>
+                    <a:bodyPr/>
+                    <a:lstStyle/>
+                    <a:p>
+                      <a:r>
+                        <a:rPr sz="1500" b="0"/>
                         <a:t>0.0336</a:t>
                       </a:r>
                     </a:p>
@@ -5313,7 +5418,7 @@
                     <a:p>
                       <a:r>
                         <a:rPr sz="1500" b="0"/>
-                        <a:t>p = 0.54: unabhängig</a:t>
+                        <a:t>annähernd unabhängig</a:t>
                       </a:r>
                     </a:p>
                   </a:txBody>
@@ -5332,7 +5437,7 @@
         </p:nvSpPr>
         <p:spPr>
           <a:xfrm>
-            <a:off x="540000" y="5760000"/>
+            <a:off x="540000" y="5688000"/>
             <a:ext cx="11160000" cy="540000"/>
           </a:xfrm>
           <a:prstGeom prst="rect">
@@ -5358,7 +5463,46 @@
                 </a:solidFill>
                 <a:latin typeface="Calibri"/>
               </a:rPr>
-              <a:t>Insgesamt abhängig, innerhalb der Fachbereiche (bis auf A) unabhängig: bedingte Unabhängigkeit gegeben Fachbereich</a:t>
+              <a:t>Insgesamt abhängig, innerhalb der Fachbereiche (bis auf A) annähernd unabhängig</a:t>
+            </a:r>
+          </a:p>
+        </p:txBody>
+      </p:sp>
+      <p:sp>
+        <p:nvSpPr>
+          <p:cNvPr id="8" name="TextBox 7"/>
+          <p:cNvSpPr txBox="1"/>
+          <p:nvPr/>
+        </p:nvSpPr>
+        <p:spPr>
+          <a:xfrm>
+            <a:off x="540000" y="6372000"/>
+            <a:ext cx="8640000" cy="360000"/>
+          </a:xfrm>
+          <a:prstGeom prst="rect">
+            <a:avLst/>
+          </a:prstGeom>
+          <a:noFill/>
+        </p:spPr>
+        <p:txBody>
+          <a:bodyPr wrap="square">
+            <a:spAutoFit/>
+          </a:bodyPr>
+          <a:lstStyle/>
+          <a:p>
+            <a:pPr>
+              <a:spcAft>
+                <a:spcPts val="495"/>
+              </a:spcAft>
+            </a:pPr>
+            <a:r>
+              <a:rPr sz="1100" b="0">
+                <a:solidFill>
+                  <a:srgbClr val="52514E"/>
+                </a:solidFill>
+                <a:latin typeface="Calibri"/>
+              </a:rPr>
+              <a:t>Eigene Berechnung; Schnauss (o. J.-b, Folie 34); Daten: Bickel et al. (1975)</a:t>
             </a:r>
           </a:p>
         </p:txBody>
@@ -5552,7 +5696,7 @@
                 </a:solidFill>
                 <a:latin typeface="Calibri"/>
               </a:rPr>
-              <a:t>•  Je Fachbereich: kein Nachteil für Frauen; bedingt auf den Fachbereich meist unabhängig</a:t>
+              <a:t>•  Je Fachbereich: kein Nachteil für Frauen; gegeben den Fachbereich annähernd unabhängig</a:t>
             </a:r>
           </a:p>
           <a:p>
@@ -5617,6 +5761,45 @@
                 <a:latin typeface="Calibri"/>
               </a:rPr>
               <a:t>•  Python: Dieselben Funktionen für Gesamtanalyse, 6 Fachbereiche und Standardisierung</a:t>
+            </a:r>
+          </a:p>
+        </p:txBody>
+      </p:sp>
+      <p:sp>
+        <p:nvSpPr>
+          <p:cNvPr id="6" name="TextBox 5"/>
+          <p:cNvSpPr txBox="1"/>
+          <p:nvPr/>
+        </p:nvSpPr>
+        <p:spPr>
+          <a:xfrm>
+            <a:off x="540000" y="6372000"/>
+            <a:ext cx="8640000" cy="360000"/>
+          </a:xfrm>
+          <a:prstGeom prst="rect">
+            <a:avLst/>
+          </a:prstGeom>
+          <a:noFill/>
+        </p:spPr>
+        <p:txBody>
+          <a:bodyPr wrap="square">
+            <a:spAutoFit/>
+          </a:bodyPr>
+          <a:lstStyle/>
+          <a:p>
+            <a:pPr>
+              <a:spcAft>
+                <a:spcPts val="495"/>
+              </a:spcAft>
+            </a:pPr>
+            <a:r>
+              <a:rPr sz="1100" b="0">
+                <a:solidFill>
+                  <a:srgbClr val="52514E"/>
+                </a:solidFill>
+                <a:latin typeface="Calibri"/>
+              </a:rPr>
+              <a:t>Quellen: Bickel et al. (1975); Simpson (1951)</a:t>
             </a:r>
           </a:p>
         </p:txBody>
@@ -5716,7 +5899,7 @@
                 </a:solidFill>
                 <a:latin typeface="Calibri"/>
               </a:rPr>
-              <a:t>Quellen · Fragen?</a:t>
+              <a:t>Literaturverzeichnis · Fragen?</a:t>
             </a:r>
           </a:p>
         </p:txBody>
@@ -5768,8 +5951,8 @@
         </p:nvSpPr>
         <p:spPr>
           <a:xfrm>
-            <a:off x="540000" y="1224000"/>
-            <a:ext cx="10980000" cy="4680000"/>
+            <a:off x="540000" y="1152000"/>
+            <a:ext cx="11160000" cy="5040000"/>
           </a:xfrm>
           <a:prstGeom prst="rect">
             <a:avLst/>
@@ -5784,81 +5967,255 @@
           <a:p>
             <a:pPr>
               <a:spcAft>
-                <a:spcPts val="675"/>
-              </a:spcAft>
-            </a:pPr>
-            <a:r>
-              <a:rPr sz="1500" b="0">
+                <a:spcPts val="500"/>
+              </a:spcAft>
+            </a:pPr>
+            <a:r>
+              <a:rPr sz="1300" i="0">
                 <a:solidFill>
                   <a:srgbClr val="52514E"/>
                 </a:solidFill>
                 <a:latin typeface="Calibri"/>
               </a:rPr>
-              <a:t>•  Bickel, P. J., Hammel, E. A. &amp; O'Connell, J. W. (1975). Sex Bias in Graduate Admissions: Data from Berkeley. Science, 187(4175), 398–404.</a:t>
-            </a:r>
-          </a:p>
-          <a:p>
-            <a:pPr>
-              <a:spcAft>
-                <a:spcPts val="675"/>
-              </a:spcAft>
-            </a:pPr>
-            <a:r>
-              <a:rPr sz="1500" b="0">
+              <a:t>Bickel, P. J., Hammel, E. A., &amp; O'Connell, J. W. (1975). Sex bias in graduate admissions: Data from Berkeley. </a:t>
+            </a:r>
+            <a:r>
+              <a:rPr sz="1300" i="1">
                 <a:solidFill>
                   <a:srgbClr val="52514E"/>
                 </a:solidFill>
                 <a:latin typeface="Calibri"/>
               </a:rPr>
-              <a:t>•  McKinney, W. (2018). Datenanalyse mit Python (2. Aufl.). O'Reilly. Abschnitt 3.2 Funktionen.</a:t>
-            </a:r>
-          </a:p>
-          <a:p>
-            <a:pPr>
-              <a:spcAft>
-                <a:spcPts val="675"/>
-              </a:spcAft>
-            </a:pPr>
-            <a:r>
-              <a:rPr sz="1500" b="0">
+              <a:t>Science, 187</a:t>
+            </a:r>
+            <a:r>
+              <a:rPr sz="1300" i="0">
                 <a:solidFill>
                   <a:srgbClr val="52514E"/>
                 </a:solidFill>
                 <a:latin typeface="Calibri"/>
               </a:rPr>
-              <a:t>•  Newbold, P., Carlson, W. &amp; Thorne, B. (2013). Statistics for Business and Economics (8th ed.). Pearson.</a:t>
-            </a:r>
-          </a:p>
-          <a:p>
-            <a:pPr>
-              <a:spcAft>
-                <a:spcPts val="675"/>
-              </a:spcAft>
-            </a:pPr>
-            <a:r>
-              <a:rPr sz="1500" b="0">
+              <a:t>(4175), 398–404. https://doi.org/10.1126/science.187.4175.398</a:t>
+            </a:r>
+          </a:p>
+          <a:p>
+            <a:pPr>
+              <a:spcAft>
+                <a:spcPts val="500"/>
+              </a:spcAft>
+            </a:pPr>
+            <a:r>
+              <a:rPr sz="1300" i="0">
                 <a:solidFill>
                   <a:srgbClr val="52514E"/>
                 </a:solidFill>
                 <a:latin typeface="Calibri"/>
               </a:rPr>
-              <a:t>•  ZHAW SML (HS 2026). Folienskript Statistik, Teil 3; Aufgabe 4, Tabelle 4: UCB Admissions.</a:t>
-            </a:r>
-          </a:p>
-          <a:p>
-            <a:pPr>
-              <a:spcAft>
-                <a:spcPts val="675"/>
-              </a:spcAft>
-            </a:pPr>
-            <a:r>
-              <a:rPr sz="1500" b="0">
+              <a:t>McKinney, W. (2018). </a:t>
+            </a:r>
+            <a:r>
+              <a:rPr sz="1300" i="1">
                 <a:solidFill>
                   <a:srgbClr val="52514E"/>
                 </a:solidFill>
                 <a:latin typeface="Calibri"/>
               </a:rPr>
-              <a:t>•  Code: Vortrag4_Berkeley_Analyse.ipynb</a:t>
+              <a:t>Datenanalyse mit Python</a:t>
+            </a:r>
+            <a:r>
+              <a:rPr sz="1300" i="0">
+                <a:solidFill>
+                  <a:srgbClr val="52514E"/>
+                </a:solidFill>
+                <a:latin typeface="Calibri"/>
+              </a:rPr>
+              <a:t> (2., korrigierte Aufl.). O'Reilly.</a:t>
+            </a:r>
+          </a:p>
+          <a:p>
+            <a:pPr>
+              <a:spcAft>
+                <a:spcPts val="500"/>
+              </a:spcAft>
+            </a:pPr>
+            <a:r>
+              <a:rPr sz="1300" i="0">
+                <a:solidFill>
+                  <a:srgbClr val="52514E"/>
+                </a:solidFill>
+                <a:latin typeface="Calibri"/>
+              </a:rPr>
+              <a:t>R Core Team. (o. J.). </a:t>
+            </a:r>
+            <a:r>
+              <a:rPr sz="1300" i="1">
+                <a:solidFill>
+                  <a:srgbClr val="52514E"/>
+                </a:solidFill>
+                <a:latin typeface="Calibri"/>
+              </a:rPr>
+              <a:t>UCBAdmissions: Student admissions at UC Berkeley</a:t>
+            </a:r>
+            <a:r>
+              <a:rPr sz="1300" i="0">
+                <a:solidFill>
+                  <a:srgbClr val="52514E"/>
+                </a:solidFill>
+                <a:latin typeface="Calibri"/>
+              </a:rPr>
+              <a:t> [Datensatz]. R-Paket datasets. https://github.com/wch/r-source/blob/trunk/src/library/datasets/data/UCBAdmissions.R</a:t>
+            </a:r>
+          </a:p>
+          <a:p>
+            <a:pPr>
+              <a:spcAft>
+                <a:spcPts val="500"/>
+              </a:spcAft>
+            </a:pPr>
+            <a:r>
+              <a:rPr sz="1300" i="0">
+                <a:solidFill>
+                  <a:srgbClr val="52514E"/>
+                </a:solidFill>
+                <a:latin typeface="Calibri"/>
+              </a:rPr>
+              <a:t>Schnauss, M. (o. J.-a). </a:t>
+            </a:r>
+            <a:r>
+              <a:rPr sz="1300" i="1">
+                <a:solidFill>
+                  <a:srgbClr val="52514E"/>
+                </a:solidFill>
+                <a:latin typeface="Calibri"/>
+              </a:rPr>
+              <a:t>Statistik (w.BA.XX.2Stat-WIN.XX), Teil 1: Tabellen und Diagramme</a:t>
+            </a:r>
+            <a:r>
+              <a:rPr sz="1300" i="0">
+                <a:solidFill>
+                  <a:srgbClr val="52514E"/>
+                </a:solidFill>
+                <a:latin typeface="Calibri"/>
+              </a:rPr>
+              <a:t> [Vorlesungsfolien]. ZHAW School of Management and Law.</a:t>
+            </a:r>
+          </a:p>
+          <a:p>
+            <a:pPr>
+              <a:spcAft>
+                <a:spcPts val="500"/>
+              </a:spcAft>
+            </a:pPr>
+            <a:r>
+              <a:rPr sz="1300" i="0">
+                <a:solidFill>
+                  <a:srgbClr val="52514E"/>
+                </a:solidFill>
+                <a:latin typeface="Calibri"/>
+              </a:rPr>
+              <a:t>Schnauss, M. (o. J.-b). </a:t>
+            </a:r>
+            <a:r>
+              <a:rPr sz="1300" i="1">
+                <a:solidFill>
+                  <a:srgbClr val="52514E"/>
+                </a:solidFill>
+                <a:latin typeface="Calibri"/>
+              </a:rPr>
+              <a:t>Statistik (w.BA.XX.2Stat-WIN.XX), Teil 3: Wahrscheinlichkeitsrechnung</a:t>
+            </a:r>
+            <a:r>
+              <a:rPr sz="1300" i="0">
+                <a:solidFill>
+                  <a:srgbClr val="52514E"/>
+                </a:solidFill>
+                <a:latin typeface="Calibri"/>
+              </a:rPr>
+              <a:t> [Vorlesungsfolien]. ZHAW School of Management and Law.</a:t>
+            </a:r>
+          </a:p>
+          <a:p>
+            <a:pPr>
+              <a:spcAft>
+                <a:spcPts val="500"/>
+              </a:spcAft>
+            </a:pPr>
+            <a:r>
+              <a:rPr sz="1300" i="0">
+                <a:solidFill>
+                  <a:srgbClr val="52514E"/>
+                </a:solidFill>
+                <a:latin typeface="Calibri"/>
+              </a:rPr>
+              <a:t>Simpson, E. H. (1951). The interpretation of interaction in contingency tables. </a:t>
+            </a:r>
+            <a:r>
+              <a:rPr sz="1300" i="1">
+                <a:solidFill>
+                  <a:srgbClr val="52514E"/>
+                </a:solidFill>
+                <a:latin typeface="Calibri"/>
+              </a:rPr>
+              <a:t>Journal of the Royal Statistical Society: Series B (Methodological), 13</a:t>
+            </a:r>
+            <a:r>
+              <a:rPr sz="1300" i="0">
+                <a:solidFill>
+                  <a:srgbClr val="52514E"/>
+                </a:solidFill>
+                <a:latin typeface="Calibri"/>
+              </a:rPr>
+              <a:t>(2), 238–241. https://doi.org/10.1111/j.2517-6161.1951.tb00088.x</a:t>
+            </a:r>
+          </a:p>
+          <a:p>
+            <a:pPr>
+              <a:spcAft>
+                <a:spcPts val="500"/>
+              </a:spcAft>
+            </a:pPr>
+            <a:r>
+              <a:rPr sz="1300" i="0">
+                <a:solidFill>
+                  <a:srgbClr val="52514E"/>
+                </a:solidFill>
+                <a:latin typeface="Calibri"/>
+              </a:rPr>
+              <a:t>ZHAW School of Management and Law. (2026). </a:t>
+            </a:r>
+            <a:r>
+              <a:rPr sz="1300" i="1">
+                <a:solidFill>
+                  <a:srgbClr val="52514E"/>
+                </a:solidFill>
+                <a:latin typeface="Calibri"/>
+              </a:rPr>
+              <a:t>Aufgabe 4 (Vortrag-4: Python)</a:t>
+            </a:r>
+            <a:r>
+              <a:rPr sz="1300" i="0">
+                <a:solidFill>
+                  <a:srgbClr val="52514E"/>
+                </a:solidFill>
+                <a:latin typeface="Calibri"/>
+              </a:rPr>
+              <a:t> [Aufgabenblatt].</a:t>
+            </a:r>
+          </a:p>
+          <a:p>
+            <a:pPr>
+              <a:spcAft>
+                <a:spcPts val="500"/>
+              </a:spcAft>
+            </a:pPr>
+            <a:r>
+              <a:rPr sz="1300" i="0">
+                <a:solidFill>
+                  <a:srgbClr val="52514E"/>
+                </a:solidFill>
+                <a:latin typeface="Calibri"/>
+              </a:rPr>
+              <a:t>Code und Ausarbeitung: Vortrag4_Berkeley_Analyse.ipynb, Vortrag4_Ausarbeitung.docx</a:t>
             </a:r>
           </a:p>
         </p:txBody>
@@ -6036,7 +6393,7 @@
                 </a:solidFill>
                 <a:latin typeface="Calibri"/>
               </a:rPr>
-              <a:t>•  4 526 Bewerbungen für ein Graduate-Studium in 6 Fachbereichen (A bis F)</a:t>
+              <a:t>•  4 526 Bewerbungen für ein Graduate-Studium an den 6 grössten Fachbereichen (A bis F)</a:t>
             </a:r>
           </a:p>
           <a:p>
@@ -6068,7 +6425,7 @@
                 </a:solidFill>
                 <a:latin typeface="Calibri"/>
               </a:rPr>
-              <a:t>•  Aufgabe (a): Funktionen in Python (McKinney 2018, Abschnitt 3.2)</a:t>
+              <a:t>•  Aufgabe (a): Funktionen in Python (McKinney, 2018, Abschnitt 3.2)</a:t>
             </a:r>
           </a:p>
           <a:p>
@@ -6101,6 +6458,45 @@
                 <a:latin typeface="Calibri"/>
               </a:rPr>
               <a:t>•  Aufgabe (c): Verteilungen vergleichen, stochastische Unabhängigkeit prüfen</a:t>
+            </a:r>
+          </a:p>
+        </p:txBody>
+      </p:sp>
+      <p:sp>
+        <p:nvSpPr>
+          <p:cNvPr id="6" name="TextBox 5"/>
+          <p:cNvSpPr txBox="1"/>
+          <p:nvPr/>
+        </p:nvSpPr>
+        <p:spPr>
+          <a:xfrm>
+            <a:off x="540000" y="6372000"/>
+            <a:ext cx="8640000" cy="360000"/>
+          </a:xfrm>
+          <a:prstGeom prst="rect">
+            <a:avLst/>
+          </a:prstGeom>
+          <a:noFill/>
+        </p:spPr>
+        <p:txBody>
+          <a:bodyPr wrap="square">
+            <a:spAutoFit/>
+          </a:bodyPr>
+          <a:lstStyle/>
+          <a:p>
+            <a:pPr>
+              <a:spcAft>
+                <a:spcPts val="495"/>
+              </a:spcAft>
+            </a:pPr>
+            <a:r>
+              <a:rPr sz="1100" b="0">
+                <a:solidFill>
+                  <a:srgbClr val="52514E"/>
+                </a:solidFill>
+                <a:latin typeface="Calibri"/>
+              </a:rPr>
+              <a:t>Quellen: Bickel et al. (1975); ZHAW SML (2026)</a:t>
             </a:r>
           </a:p>
         </p:txBody>
@@ -6367,7 +6763,7 @@
                 </a:solidFill>
                 <a:latin typeface="Consolas"/>
               </a:rPr>
-              <a:t>def vierfeldertafel(daten, fachbereich=None):</a:t>
+              <a:t>def kreuztabelle(daten, fachbereich=None):</a:t>
             </a:r>
           </a:p>
           <a:p>
@@ -6544,6 +6940,45 @@
                 <a:latin typeface="Consolas"/>
               </a:rPr>
               <a:t>quote, anteil = kennzahlen(89, 19, 1835)  # Tupel entpacken</a:t>
+            </a:r>
+          </a:p>
+        </p:txBody>
+      </p:sp>
+      <p:sp>
+        <p:nvSpPr>
+          <p:cNvPr id="7" name="TextBox 6"/>
+          <p:cNvSpPr txBox="1"/>
+          <p:nvPr/>
+        </p:nvSpPr>
+        <p:spPr>
+          <a:xfrm>
+            <a:off x="540000" y="6372000"/>
+            <a:ext cx="8640000" cy="360000"/>
+          </a:xfrm>
+          <a:prstGeom prst="rect">
+            <a:avLst/>
+          </a:prstGeom>
+          <a:noFill/>
+        </p:spPr>
+        <p:txBody>
+          <a:bodyPr wrap="square">
+            <a:spAutoFit/>
+          </a:bodyPr>
+          <a:lstStyle/>
+          <a:p>
+            <a:pPr>
+              <a:spcAft>
+                <a:spcPts val="495"/>
+              </a:spcAft>
+            </a:pPr>
+            <a:r>
+              <a:rPr sz="1100" b="0">
+                <a:solidFill>
+                  <a:srgbClr val="52514E"/>
+                </a:solidFill>
+                <a:latin typeface="Calibri"/>
+              </a:rPr>
+              <a:t>Quelle: McKinney (2018, S. 71–74)</a:t>
             </a:r>
           </a:p>
         </p:txBody>
@@ -6819,7 +7254,7 @@
                 </a:solidFill>
                 <a:latin typeface="Consolas"/>
               </a:rPr>
-              <a:t>pruefe_streng = partial(pruefe_unabhaengigkeit, alpha=0.01)</a:t>
+              <a:t>quote_frauen = partial(bedingte_quote, geschlecht="Frauen")</a:t>
             </a:r>
           </a:p>
           <a:p>
@@ -6899,7 +7334,7 @@
                 </a:solidFill>
                 <a:latin typeface="Consolas"/>
               </a:rPr>
-              <a:t>        yield fb, pruefe_unabhaengigkeit(vierfeldertafel(daten, fb))</a:t>
+              <a:t>        yield fb, pruefe_unabhaengigkeit(kreuztabelle(daten, fachbereich=fb))</a:t>
             </a:r>
           </a:p>
           <a:p>
@@ -7012,6 +7447,45 @@
                 <a:latin typeface="Consolas"/>
               </a:rPr>
               <a:t>        raise ValueError(f"Ungültiger Tabellenwert: {wert!r}")</a:t>
+            </a:r>
+          </a:p>
+        </p:txBody>
+      </p:sp>
+      <p:sp>
+        <p:nvSpPr>
+          <p:cNvPr id="6" name="TextBox 5"/>
+          <p:cNvSpPr txBox="1"/>
+          <p:nvPr/>
+        </p:nvSpPr>
+        <p:spPr>
+          <a:xfrm>
+            <a:off x="540000" y="6372000"/>
+            <a:ext cx="8640000" cy="360000"/>
+          </a:xfrm>
+          <a:prstGeom prst="rect">
+            <a:avLst/>
+          </a:prstGeom>
+          <a:noFill/>
+        </p:spPr>
+        <p:txBody>
+          <a:bodyPr wrap="square">
+            <a:spAutoFit/>
+          </a:bodyPr>
+          <a:lstStyle/>
+          <a:p>
+            <a:pPr>
+              <a:spcAft>
+                <a:spcPts val="495"/>
+              </a:spcAft>
+            </a:pPr>
+            <a:r>
+              <a:rPr sz="1100" b="0">
+                <a:solidFill>
+                  <a:srgbClr val="52514E"/>
+                </a:solidFill>
+                <a:latin typeface="Calibri"/>
+              </a:rPr>
+              <a:t>Quelle: McKinney (2018, S. 74–81)</a:t>
             </a:r>
           </a:p>
         </p:txBody>
@@ -7179,27 +7653,27 @@
           <a:p>
             <a:pPr>
               <a:spcAft>
-                <a:spcPts val="855"/>
-              </a:spcAft>
-            </a:pPr>
-            <a:r>
-              <a:rPr sz="1900" b="0">
+                <a:spcPts val="810"/>
+              </a:spcAft>
+            </a:pPr>
+            <a:r>
+              <a:rPr sz="1800" b="0">
                 <a:solidFill>
                   <a:srgbClr val="52514E"/>
                 </a:solidFill>
                 <a:latin typeface="Calibri"/>
               </a:rPr>
-              <a:t>•  Tabelle 4 enthält nur Prozente, deshalb Anzahlen aus dem Originaldatensatz (Bickel et al. 1975); der Code prüft sie gegen Tabelle 4: 0 Abweichungen</a:t>
-            </a:r>
-          </a:p>
-          <a:p>
-            <a:pPr>
-              <a:spcAft>
-                <a:spcPts val="855"/>
-              </a:spcAft>
-            </a:pPr>
-            <a:r>
-              <a:rPr sz="1900" b="0">
+              <a:t>•  Tabelle 4 enthält nur Prozente, deshalb Anzahlen aus dem Originaldatensatz; der Code prüft sie gegen Tabelle 4: 0 Abweichungen</a:t>
+            </a:r>
+          </a:p>
+          <a:p>
+            <a:pPr>
+              <a:spcAft>
+                <a:spcPts val="810"/>
+              </a:spcAft>
+            </a:pPr>
+            <a:r>
+              <a:rPr sz="1800" b="0">
                 <a:solidFill>
                   <a:srgbClr val="52514E"/>
                 </a:solidFill>
@@ -7211,11 +7685,11 @@
           <a:p>
             <a:pPr>
               <a:spcAft>
-                <a:spcPts val="855"/>
-              </a:spcAft>
-            </a:pPr>
-            <a:r>
-              <a:rPr sz="1900" b="0">
+                <a:spcPts val="810"/>
+              </a:spcAft>
+            </a:pPr>
+            <a:r>
+              <a:rPr sz="1800" b="0">
                 <a:solidFill>
                   <a:srgbClr val="52514E"/>
                 </a:solidFill>
@@ -7227,11 +7701,11 @@
           <a:p>
             <a:pPr>
               <a:spcAft>
-                <a:spcPts val="855"/>
-              </a:spcAft>
-            </a:pPr>
-            <a:r>
-              <a:rPr sz="1900" b="0">
+                <a:spcPts val="810"/>
+              </a:spcAft>
+            </a:pPr>
+            <a:r>
+              <a:rPr sz="1800" b="0">
                 <a:solidFill>
                   <a:srgbClr val="52514E"/>
                 </a:solidFill>
@@ -7243,17 +7717,72 @@
           <a:p>
             <a:pPr>
               <a:spcAft>
-                <a:spcPts val="855"/>
-              </a:spcAft>
-            </a:pPr>
-            <a:r>
-              <a:rPr sz="1900" b="1">
+                <a:spcPts val="810"/>
+              </a:spcAft>
+            </a:pPr>
+            <a:r>
+              <a:rPr sz="1800" b="0">
                 <a:solidFill>
                   <a:srgbClr val="52514E"/>
                 </a:solidFill>
                 <a:latin typeface="Calibri"/>
               </a:rPr>
-              <a:t>•  pandas: Tabellen · numpy: Rechnen · matplotlib: Grafiken · scipy.stats: Chi-Quadrat-Test</a:t>
+              <a:t>•  Diagramme wie im Kurs: Säulen-, gruppiertes Säulen- und Streudiagramm</a:t>
+            </a:r>
+          </a:p>
+          <a:p>
+            <a:pPr>
+              <a:spcAft>
+                <a:spcPts val="810"/>
+              </a:spcAft>
+            </a:pPr>
+            <a:r>
+              <a:rPr sz="1800" b="1">
+                <a:solidFill>
+                  <a:srgbClr val="52514E"/>
+                </a:solidFill>
+                <a:latin typeface="Calibri"/>
+              </a:rPr>
+              <a:t>•  pandas: Tabellen · numpy: Rechnen · matplotlib: Diagramme · re/functools: Standardbibliothek</a:t>
+            </a:r>
+          </a:p>
+        </p:txBody>
+      </p:sp>
+      <p:sp>
+        <p:nvSpPr>
+          <p:cNvPr id="6" name="TextBox 5"/>
+          <p:cNvSpPr txBox="1"/>
+          <p:nvPr/>
+        </p:nvSpPr>
+        <p:spPr>
+          <a:xfrm>
+            <a:off x="540000" y="6372000"/>
+            <a:ext cx="8640000" cy="360000"/>
+          </a:xfrm>
+          <a:prstGeom prst="rect">
+            <a:avLst/>
+          </a:prstGeom>
+          <a:noFill/>
+        </p:spPr>
+        <p:txBody>
+          <a:bodyPr wrap="square">
+            <a:spAutoFit/>
+          </a:bodyPr>
+          <a:lstStyle/>
+          <a:p>
+            <a:pPr>
+              <a:spcAft>
+                <a:spcPts val="495"/>
+              </a:spcAft>
+            </a:pPr>
+            <a:r>
+              <a:rPr sz="1100" b="0">
+                <a:solidFill>
+                  <a:srgbClr val="52514E"/>
+                </a:solidFill>
+                <a:latin typeface="Calibri"/>
+              </a:rPr>
+              <a:t>Quellen: R Core Team (o. J.); Schnauss (o. J.-a, Folien 16, 42, 45; o. J.-b, Folie 37)</a:t>
             </a:r>
           </a:p>
         </p:txBody>
@@ -7414,7 +7943,7 @@
         <p:spPr>
           <a:xfrm>
             <a:off x="540000" y="1152000"/>
-            <a:ext cx="7457143" cy="5220000"/>
+            <a:ext cx="7200000" cy="5040000"/>
           </a:xfrm>
           <a:prstGeom prst="rect">
             <a:avLst/>
@@ -7520,6 +8049,45 @@
                 <a:latin typeface="Calibri"/>
               </a:rPr>
               <a:t>•  Also Diskriminierung?</a:t>
+            </a:r>
+          </a:p>
+        </p:txBody>
+      </p:sp>
+      <p:sp>
+        <p:nvSpPr>
+          <p:cNvPr id="7" name="TextBox 6"/>
+          <p:cNvSpPr txBox="1"/>
+          <p:nvPr/>
+        </p:nvSpPr>
+        <p:spPr>
+          <a:xfrm>
+            <a:off x="540000" y="6372000"/>
+            <a:ext cx="8640000" cy="360000"/>
+          </a:xfrm>
+          <a:prstGeom prst="rect">
+            <a:avLst/>
+          </a:prstGeom>
+          <a:noFill/>
+        </p:spPr>
+        <p:txBody>
+          <a:bodyPr wrap="square">
+            <a:spAutoFit/>
+          </a:bodyPr>
+          <a:lstStyle/>
+          <a:p>
+            <a:pPr>
+              <a:spcAft>
+                <a:spcPts val="495"/>
+              </a:spcAft>
+            </a:pPr>
+            <a:r>
+              <a:rPr sz="1100" b="0">
+                <a:solidFill>
+                  <a:srgbClr val="52514E"/>
+                </a:solidFill>
+                <a:latin typeface="Calibri"/>
+              </a:rPr>
+              <a:t>Eigene Darstellung; Daten: Bickel et al. (1975)</a:t>
             </a:r>
           </a:p>
         </p:txBody>
@@ -7658,7 +8226,7 @@
                 </a:solidFill>
                 <a:latin typeface="Calibri"/>
               </a:rPr>
-              <a:t>Sprecher/in 3</a:t>
+              <a:t>Sprecher/in 2</a:t>
             </a:r>
           </a:p>
         </p:txBody>
@@ -7753,7 +8321,46 @@
                 </a:solidFill>
                 <a:latin typeface="Calibri"/>
               </a:rPr>
-              <a:t>•  FB C und E: −2.8 bzw. −3.8 Prozentpunkte</a:t>
+              <a:t>•  FB C und E: −2.9 bzw. −3.8 Prozentpunkte</a:t>
+            </a:r>
+          </a:p>
+        </p:txBody>
+      </p:sp>
+      <p:sp>
+        <p:nvSpPr>
+          <p:cNvPr id="7" name="TextBox 6"/>
+          <p:cNvSpPr txBox="1"/>
+          <p:nvPr/>
+        </p:nvSpPr>
+        <p:spPr>
+          <a:xfrm>
+            <a:off x="540000" y="6372000"/>
+            <a:ext cx="8640000" cy="360000"/>
+          </a:xfrm>
+          <a:prstGeom prst="rect">
+            <a:avLst/>
+          </a:prstGeom>
+          <a:noFill/>
+        </p:spPr>
+        <p:txBody>
+          <a:bodyPr wrap="square">
+            <a:spAutoFit/>
+          </a:bodyPr>
+          <a:lstStyle/>
+          <a:p>
+            <a:pPr>
+              <a:spcAft>
+                <a:spcPts val="495"/>
+              </a:spcAft>
+            </a:pPr>
+            <a:r>
+              <a:rPr sz="1100" b="0">
+                <a:solidFill>
+                  <a:srgbClr val="52514E"/>
+                </a:solidFill>
+                <a:latin typeface="Calibri"/>
+              </a:rPr>
+              <a:t>Eigene Darstellung; Daten: ZHAW SML (2026), Tabelle 4</a:t>
             </a:r>
           </a:p>
         </p:txBody>
@@ -7892,7 +8499,7 @@
                 </a:solidFill>
                 <a:latin typeface="Calibri"/>
               </a:rPr>
-              <a:t>Sprecher/in 3</a:t>
+              <a:t>Sprecher/in 2</a:t>
             </a:r>
           </a:p>
         </p:txBody>
@@ -8000,6 +8607,45 @@
           </a:p>
         </p:txBody>
       </p:sp>
+      <p:sp>
+        <p:nvSpPr>
+          <p:cNvPr id="8" name="TextBox 7"/>
+          <p:cNvSpPr txBox="1"/>
+          <p:nvPr/>
+        </p:nvSpPr>
+        <p:spPr>
+          <a:xfrm>
+            <a:off x="540000" y="6372000"/>
+            <a:ext cx="8640000" cy="360000"/>
+          </a:xfrm>
+          <a:prstGeom prst="rect">
+            <a:avLst/>
+          </a:prstGeom>
+          <a:noFill/>
+        </p:spPr>
+        <p:txBody>
+          <a:bodyPr wrap="square">
+            <a:spAutoFit/>
+          </a:bodyPr>
+          <a:lstStyle/>
+          <a:p>
+            <a:pPr>
+              <a:spcAft>
+                <a:spcPts val="495"/>
+              </a:spcAft>
+            </a:pPr>
+            <a:r>
+              <a:rPr sz="1100" b="0">
+                <a:solidFill>
+                  <a:srgbClr val="52514E"/>
+                </a:solidFill>
+                <a:latin typeface="Calibri"/>
+              </a:rPr>
+              <a:t>Eigene Darstellung; Daten: Bickel et al. (1975); ZHAW SML (2026)</a:t>
+            </a:r>
+          </a:p>
+        </p:txBody>
+      </p:sp>
     </p:spTree>
   </p:cSld>
   <p:clrMapOvr>
@@ -8262,6 +8908,45 @@
                 <a:latin typeface="Calibri"/>
               </a:rPr>
               <a:t>gesamtquote(quote_g[g], gewichte_alle)</a:t>
+            </a:r>
+          </a:p>
+        </p:txBody>
+      </p:sp>
+      <p:sp>
+        <p:nvSpPr>
+          <p:cNvPr id="7" name="TextBox 6"/>
+          <p:cNvSpPr txBox="1"/>
+          <p:nvPr/>
+        </p:nvSpPr>
+        <p:spPr>
+          <a:xfrm>
+            <a:off x="540000" y="6372000"/>
+            <a:ext cx="8640000" cy="360000"/>
+          </a:xfrm>
+          <a:prstGeom prst="rect">
+            <a:avLst/>
+          </a:prstGeom>
+          <a:noFill/>
+        </p:spPr>
+        <p:txBody>
+          <a:bodyPr wrap="square">
+            <a:spAutoFit/>
+          </a:bodyPr>
+          <a:lstStyle/>
+          <a:p>
+            <a:pPr>
+              <a:spcAft>
+                <a:spcPts val="495"/>
+              </a:spcAft>
+            </a:pPr>
+            <a:r>
+              <a:rPr sz="1100" b="0">
+                <a:solidFill>
+                  <a:srgbClr val="52514E"/>
+                </a:solidFill>
+                <a:latin typeface="Calibri"/>
+              </a:rPr>
+              <a:t>Eigene Darstellung und Berechnung; Schnauss (o. J.-b, Folie 37); Daten: Bickel et al. (1975)</a:t>
             </a:r>
           </a:p>
         </p:txBody>

</xml_diff>

<commit_message>
Folien: Namen der Vortragenden eingetragen
Co-Authored-By: Claude Opus 5.5 <noreply@anthropic.com>
Claude-Session: https://claude.ai/code/session_013vrRC9ggswsEWMp2ebeFzZ
</commit_message>
<xml_diff>
--- a/vortrag4/Vortrag4_Praesentation.pptx
+++ b/vortrag4/Vortrag4_Praesentation.pptx
@@ -4615,7 +4615,7 @@
                 </a:solidFill>
                 <a:latin typeface="Calibri"/>
               </a:rPr>
-              <a:t>Sprecher/in 3</a:t>
+              <a:t>Filip Lazic</a:t>
             </a:r>
           </a:p>
         </p:txBody>
@@ -5641,7 +5641,7 @@
                 </a:solidFill>
                 <a:latin typeface="Calibri"/>
               </a:rPr>
-              <a:t>Sprecher/in 3</a:t>
+              <a:t>Filip Lazic</a:t>
             </a:r>
           </a:p>
         </p:txBody>
@@ -6354,7 +6354,7 @@
                 </a:solidFill>
                 <a:latin typeface="Calibri"/>
               </a:rPr>
-              <a:t>Sprecher/in 1</a:t>
+              <a:t>Leorat Krasniqi</a:t>
             </a:r>
           </a:p>
         </p:txBody>
@@ -6635,7 +6635,7 @@
                 </a:solidFill>
                 <a:latin typeface="Calibri"/>
               </a:rPr>
-              <a:t>Sprecher/in 1</a:t>
+              <a:t>Leorat Krasniqi</a:t>
             </a:r>
           </a:p>
         </p:txBody>
@@ -7117,7 +7117,7 @@
                 </a:solidFill>
                 <a:latin typeface="Calibri"/>
               </a:rPr>
-              <a:t>Sprecher/in 1</a:t>
+              <a:t>Leorat Krasniqi</a:t>
             </a:r>
           </a:p>
         </p:txBody>
@@ -7624,7 +7624,7 @@
                 </a:solidFill>
                 <a:latin typeface="Calibri"/>
               </a:rPr>
-              <a:t>Sprecher/in 2</a:t>
+              <a:t>Teoman-Doganay Lam</a:t>
             </a:r>
           </a:p>
         </p:txBody>
@@ -7921,7 +7921,7 @@
                 </a:solidFill>
                 <a:latin typeface="Calibri"/>
               </a:rPr>
-              <a:t>Sprecher/in 2</a:t>
+              <a:t>Teoman-Doganay Lam</a:t>
             </a:r>
           </a:p>
         </p:txBody>
@@ -8226,7 +8226,7 @@
                 </a:solidFill>
                 <a:latin typeface="Calibri"/>
               </a:rPr>
-              <a:t>Sprecher/in 2</a:t>
+              <a:t>Teoman-Doganay Lam</a:t>
             </a:r>
           </a:p>
         </p:txBody>
@@ -8499,7 +8499,7 @@
                 </a:solidFill>
                 <a:latin typeface="Calibri"/>
               </a:rPr>
-              <a:t>Sprecher/in 2</a:t>
+              <a:t>Teoman-Doganay Lam</a:t>
             </a:r>
           </a:p>
         </p:txBody>
@@ -8780,7 +8780,7 @@
                 </a:solidFill>
                 <a:latin typeface="Calibri"/>
               </a:rPr>
-              <a:t>Sprecher/in 3</a:t>
+              <a:t>Filip Lazic</a:t>
             </a:r>
           </a:p>
         </p:txBody>

</xml_diff>

<commit_message>
Titel korrigiert (Simpson-Paradoxon), Rundungshinweise ergänzt
- Selbst erfundenen Titel «Berkeley-Paradoxon» durch den Fachbegriff
  «Simpson-Paradoxon an der UC Berkeley» ersetzt (Ausarbeitung, Notebook,
  Folien, README)
- Hinweis ergänzt, dass Differenzen aus den ungerundeten Anzahlen stammen
  (C: −2.9 statt −2.8 aus gerundeten Werten; 14.2 statt 14.1)

Co-Authored-By: Claude Opus 5.5 <noreply@anthropic.com>
Claude-Session: https://claude.ai/code/session_013vrRC9ggswsEWMp2ebeFzZ
</commit_message>
<xml_diff>
--- a/vortrag4/Vortrag4_Praesentation.pptx
+++ b/vortrag4/Vortrag4_Praesentation.pptx
@@ -4340,7 +4340,62 @@
         </p:nvSpPr>
         <p:spPr>
           <a:xfrm>
-            <a:off x="720000" y="1800000"/>
+            <a:off x="720000" y="1296000"/>
+            <a:ext cx="10800000" cy="1440000"/>
+          </a:xfrm>
+          <a:prstGeom prst="rect">
+            <a:avLst/>
+          </a:prstGeom>
+          <a:noFill/>
+        </p:spPr>
+        <p:txBody>
+          <a:bodyPr wrap="square">
+            <a:spAutoFit/>
+          </a:bodyPr>
+          <a:lstStyle/>
+          <a:p>
+            <a:pPr>
+              <a:spcAft>
+                <a:spcPts val="1980"/>
+              </a:spcAft>
+            </a:pPr>
+            <a:r>
+              <a:rPr sz="4400" b="1">
+                <a:solidFill>
+                  <a:srgbClr val="FFFFFF"/>
+                </a:solidFill>
+                <a:latin typeface="Calibri"/>
+              </a:rPr>
+              <a:t>Das Simpson-Paradoxon</a:t>
+            </a:r>
+          </a:p>
+          <a:p>
+            <a:pPr>
+              <a:spcAft>
+                <a:spcPts val="1980"/>
+              </a:spcAft>
+            </a:pPr>
+            <a:r>
+              <a:rPr sz="4400" b="1">
+                <a:solidFill>
+                  <a:srgbClr val="FFFFFF"/>
+                </a:solidFill>
+                <a:latin typeface="Calibri"/>
+              </a:rPr>
+              <a:t>an der UC Berkeley</a:t>
+            </a:r>
+          </a:p>
+        </p:txBody>
+      </p:sp>
+      <p:sp>
+        <p:nvSpPr>
+          <p:cNvPr id="4" name="TextBox 3"/>
+          <p:cNvSpPr txBox="1"/>
+          <p:nvPr/>
+        </p:nvSpPr>
+        <p:spPr>
+          <a:xfrm>
+            <a:off x="720000" y="3240000"/>
             <a:ext cx="10800000" cy="1080000"/>
           </a:xfrm>
           <a:prstGeom prst="rect">
@@ -4356,45 +4411,6 @@
           <a:p>
             <a:pPr>
               <a:spcAft>
-                <a:spcPts val="1980"/>
-              </a:spcAft>
-            </a:pPr>
-            <a:r>
-              <a:rPr sz="4400" b="1">
-                <a:solidFill>
-                  <a:srgbClr val="FFFFFF"/>
-                </a:solidFill>
-                <a:latin typeface="Calibri"/>
-              </a:rPr>
-              <a:t>Das Berkeley-Paradoxon</a:t>
-            </a:r>
-          </a:p>
-        </p:txBody>
-      </p:sp>
-      <p:sp>
-        <p:nvSpPr>
-          <p:cNvPr id="4" name="TextBox 3"/>
-          <p:cNvSpPr txBox="1"/>
-          <p:nvPr/>
-        </p:nvSpPr>
-        <p:spPr>
-          <a:xfrm>
-            <a:off x="720000" y="2880000"/>
-            <a:ext cx="10800000" cy="1080000"/>
-          </a:xfrm>
-          <a:prstGeom prst="rect">
-            <a:avLst/>
-          </a:prstGeom>
-          <a:noFill/>
-        </p:spPr>
-        <p:txBody>
-          <a:bodyPr wrap="square">
-            <a:spAutoFit/>
-          </a:bodyPr>
-          <a:lstStyle/>
-          <a:p>
-            <a:pPr>
-              <a:spcAft>
                 <a:spcPts val="990"/>
               </a:spcAft>
             </a:pPr>
@@ -4405,7 +4421,7 @@
                 </a:solidFill>
                 <a:latin typeface="Calibri"/>
               </a:rPr>
-              <a:t>Zulassungen an der UC Berkeley 1973:</a:t>
+              <a:t>Zulassungen 1973:</a:t>
             </a:r>
           </a:p>
           <a:p>

</xml_diff>

<commit_message>
Inhaltliche Überarbeitung: Aussagen an Quellen und Daten angepasst
- Befund von Bickel et al. (1975) genauer wiedergegeben
- Simpson-Paradoxon: «kann auftreten» statt «tritt auf»; Beispielcharakter
  der Berkeley-Daten wie in der Quelle formuliert
- Zulassungsquoten in Tabelle 4 korrekt als P(Z | W, F_i) bezeichnet
- «knapp zwei Drittel» statt «rund zwei Drittel» (64.4 % und 63.2 %)
- Fazit: «keine systematische Benachteiligung» statt «nicht benachteiligt»
- Zu lange Codezeilen in der Ausarbeitung gekürzt

Co-Authored-By: Claude Opus 5.5 <noreply@anthropic.com>
Claude-Session: https://claude.ai/code/session_013vrRC9ggswsEWMp2ebeFzZ
</commit_message>
<xml_diff>
--- a/vortrag4/Vortrag4_Praesentation.pptx
+++ b/vortrag4/Vortrag4_Praesentation.pptx
@@ -5712,7 +5712,7 @@
                 </a:solidFill>
                 <a:latin typeface="Calibri"/>
               </a:rPr>
-              <a:t>•  Je Fachbereich: kein Nachteil für Frauen; gegeben den Fachbereich annähernd unabhängig</a:t>
+              <a:t>•  Je Fachbereich: kein systematischer Nachteil für Frauen; gegeben den Fachbereich annähernd unabhängig</a:t>
             </a:r>
           </a:p>
           <a:p>
@@ -8203,7 +8203,7 @@
                 </a:solidFill>
                 <a:latin typeface="Calibri"/>
               </a:rPr>
-              <a:t>(c) Je Fachbereich: kein Nachteil für Frauen</a:t>
+              <a:t>(c) Kein systematischer Nachteil je Fachbereich</a:t>
             </a:r>
           </a:p>
         </p:txBody>

</xml_diff>

<commit_message>
Sprechtext für alle 18 Folien mit Kriterien-Check und Fragerunde; Notizen der PPTX aktualisiert
Co-Authored-By: Claude Opus 5.5 <noreply@anthropic.com>
Claude-Session: https://claude.ai/code/session_013vrRC9ggswsEWMp2ebeFzZ
</commit_message>
<xml_diff>
--- a/vortrag4/Vortrag4_Praesentation.pptx
+++ b/vortrag4/Vortrag4_Praesentation.pptx
@@ -2266,10 +2266,26 @@
           <a:lstStyle/>
           <a:p>
             <a:r>
-              <a:rPr lang="en-US" dirty="0"/>
-              <a:t>Alle drei. Begrüssung und kurze Vorstellung der Gruppe. Ablauf: Leorat zeigt die Ausgangslage und Aufgabe (a), Funktionen in Python. Teoman zeigt unsere Vorüberlegungen, Aufgabe (b) und den ersten Teil von (c). Filip erklärt die totale Wahrscheinlichkeit, die stochastische Unabhängigkeit und das Fazit. Dauer ca. 15 Minuten.</a:t>
-            </a:r>
-            <a:endParaRPr lang="en-US" dirty="0"/>
+              <a:t>Alle · 0:00–0:30</a:t>
+            </a:r>
+          </a:p>
+          <a:p/>
+          <a:p>
+            <a:r>
+              <a:t>Guten Tag zusammen. Wir sind Leorat Krasniqi, Teoman-Doganay Lam und Filip Lazic.</a:t>
+            </a:r>
+          </a:p>
+          <a:p/>
+          <a:p>
+            <a:r>
+              <a:t>Unser Thema ist ein Klassiker der Statistik: die Zulassungen an der University of California in Berkeley im Jahr 1973. An diesem Beispiel zeigen wir, wie man mit Python Daten auswertet und darstellt, und warum ein einzelner Durchschnittswert manchmal genau das Falsche erzählt.</a:t>
+            </a:r>
+          </a:p>
+          <a:p/>
+          <a:p>
+            <a:r>
+              <a:t>Merksatz: Wir zeigen Python, Visualisierung und stochastische Unabhängigkeit an einem echten Datensatz.</a:t>
+            </a:r>
           </a:p>
         </p:txBody>
       </p:sp>
@@ -2354,10 +2370,14 @@
           <a:lstStyle/>
           <a:p>
             <a:r>
-              <a:rPr lang="en-US" dirty="0"/>
-              <a:t>Teoman-Doganay Lam. Jetzt Aufgabe (c): Wir schauen genauer hin.</a:t>
-            </a:r>
-            <a:endParaRPr lang="en-US" dirty="0"/>
+              <a:t>Teoman-Doganay Lam · 8:00–8:10</a:t>
+            </a:r>
+          </a:p>
+          <a:p/>
+          <a:p>
+            <a:r>
+              <a:t>Teil c: Wir schauen genauer hin.</a:t>
+            </a:r>
           </a:p>
         </p:txBody>
       </p:sp>
@@ -2442,10 +2462,38 @@
           <a:lstStyle/>
           <a:p>
             <a:r>
-              <a:rPr lang="en-US" dirty="0"/>
-              <a:t>Teoman-Doganay Lam. Jetzt schauen wir in die einzelnen Fachbereiche, denn dort wird über die Zulassung entschieden. Das Bild dreht sich: In vier von sechs Fachbereichen haben Frauen die höhere Quote, in A sogar um 20 Prozentpunkte. Nur in C und E liegen die Männer leicht vorne, mit knapp 3 und knapp 4 Prozentpunkten. Wie kann das sein, wenn die Gesamtquote der Frauen so viel tiefer ist?</a:t>
-            </a:r>
-            <a:endParaRPr lang="en-US" dirty="0"/>
+              <a:t>Teoman-Doganay Lam · 8:10–9:10</a:t>
+            </a:r>
+          </a:p>
+          <a:p/>
+          <a:p>
+            <a:r>
+              <a:t>Über die Zulassung entscheidet nicht die Universität als Ganzes, sondern jeder Fachbereich für sich. Deshalb vergleichen wir die Quoten innerhalb der Fachbereiche. Im Code ist das dieselbe Funktion, nur mit dem Argument fachbereich.</a:t>
+            </a:r>
+          </a:p>
+          <a:p/>
+          <a:p>
+            <a:r>
+              <a:t>Und das Bild dreht sich: In vier von sechs Fachbereichen haben Frauen die höhere Quote. In Fachbereich A sind es sogar gut 20 Prozentpunkte mehr, 82.4 gegen 62.1 Prozent.</a:t>
+            </a:r>
+          </a:p>
+          <a:p/>
+          <a:p>
+            <a:r>
+              <a:t>Nur in C und E liegen die Männer vorne, mit knapp 3 und knapp 4 Prozentpunkten. Unter jedem Fachbereich steht die Differenz. Wir haben sie aus den ungerundeten Anzahlen berechnet, deshalb steht bei C minus 2.9.</a:t>
+            </a:r>
+          </a:p>
+          <a:p/>
+          <a:p>
+            <a:r>
+              <a:t>Wie passt das zur viel tieferen Gesamtquote der Frauen?</a:t>
+            </a:r>
+          </a:p>
+          <a:p/>
+          <a:p>
+            <a:r>
+              <a:t>Merksatz: Innerhalb der Fachbereiche gibt es keinen systematischen Nachteil für Frauen.</a:t>
+            </a:r>
           </a:p>
         </p:txBody>
       </p:sp>
@@ -2530,10 +2578,38 @@
           <a:lstStyle/>
           <a:p>
             <a:r>
-              <a:rPr lang="en-US" dirty="0"/>
-              <a:t>Teoman-Doganay Lam. Die Antwort liegt darin, wo sich Frauen und Männer beworben haben. Dunkel sind die Fachbereiche A und B, dort werden knapp zwei Drittel zugelassen. Grau sind C bis F, dort nur 6 bis 35 Prozent. Die Hälfte der Männer hat sich in A oder B beworben, von den Frauen nur 7 Prozent. Fast alle Frauen haben sich in den schwierigen Fachbereichen beworben. Die Korrelation zwischen Frauenanteil und Zulassungsquote je Fachbereich beträgt minus 0.79. Damit übergebe ich an Filip.</a:t>
-            </a:r>
-            <a:endParaRPr lang="en-US" dirty="0"/>
+              <a:t>Teoman-Doganay Lam · 9:10–10:20</a:t>
+            </a:r>
+          </a:p>
+          <a:p/>
+          <a:p>
+            <a:r>
+              <a:t>Die Antwort liegt darin, wo sich Frauen und Männer beworben haben. Dunkel sind die Fachbereiche A und B. Dort werden knapp zwei Drittel aller Bewerbungen angenommen. Grau sind C bis F mit Quoten zwischen 6 und 35 Prozent.</a:t>
+            </a:r>
+          </a:p>
+          <a:p/>
+          <a:p>
+            <a:r>
+              <a:t>Von den Männern hat sich gut die Hälfte in A oder B beworben, genau 51.5 Prozent. Von den Frauen waren es nur 7.2 Prozent. 92.8 Prozent der Frauen haben sich also in den schwierigen Fachbereichen beworben.</a:t>
+            </a:r>
+          </a:p>
+          <a:p/>
+          <a:p>
+            <a:r>
+              <a:t>Rechts sieht man den Zusammenhang über alle sechs Fachbereiche: Die Korrelation zwischen Frauenanteil und Zulassungsquote beträgt minus 0.79. Zwei Beispiele: In A sind 11.6 Prozent der Bewerbungen von Frauen, die Quote liegt bei 64.4 Prozent. In E sind es 67.3 Prozent Frauen, und die Quote liegt nur bei 25.2 Prozent.</a:t>
+            </a:r>
+          </a:p>
+          <a:p/>
+          <a:p>
+            <a:r>
+              <a:t>Damit übergebe ich an Filip.</a:t>
+            </a:r>
+          </a:p>
+          <a:p/>
+          <a:p>
+            <a:r>
+              <a:t>Merksatz: Frauen bewarben sich vor allem dort, wo es schwer ist.</a:t>
+            </a:r>
           </a:p>
         </p:txBody>
       </p:sp>
@@ -2618,10 +2694,50 @@
           <a:lstStyle/>
           <a:p>
             <a:r>
-              <a:rPr lang="en-US" dirty="0"/>
-              <a:t>Filip Lazic. Warum passt das zusammen? Wegen des Satzes der totalen Wahrscheinlichkeit, im Kurs als «alle Wege im Baumdiagramm addieren». Die Gesamtquote eines Geschlechts ist ein gewichteter Mittelwert der Quoten in den Fachbereichen, gewichtet mit der Verteilung der Bewerbungen. Frauen haben ihre grossen Gewichte genau bei den tiefen Quoten. Wir haben deshalb für beide Geschlechter dieselben Gewichte eingesetzt, nämlich die Verteilung aller Bewerbungen. Ergebnis: Frauen 43.0 Prozent, Männer 38.7 Prozent. Der Unterschied kehrt sich um. Im Code ist das dieselbe Funktion gesamtquote, nur mit anderen Gewichten.</a:t>
-            </a:r>
-            <a:endParaRPr lang="en-US" dirty="0"/>
+              <a:t>Filip Lazic · 10:20–11:40</a:t>
+            </a:r>
+          </a:p>
+          <a:p/>
+          <a:p>
+            <a:r>
+              <a:t>Danke, Teoman. Warum führt das zu einer tieferen Gesamtquote? Das erklärt der Satz der totalen Wahrscheinlichkeit. Im Folienskript heisst es: alle Wege im Baumdiagramm addieren.</a:t>
+            </a:r>
+          </a:p>
+          <a:p/>
+          <a:p>
+            <a:r>
+              <a:t>Die Formel oben sagt: Die Zulassungsquote eines Geschlechts ist die Summe über alle Fachbereiche, und zwar Anteil der Bewerbungen mal Quote im Fachbereich. Die Gesamtquote ist also ein gewichteter Mittelwert. Die Gewichte sind die Anteile, also wo man sich beworben hat.</a:t>
+            </a:r>
+          </a:p>
+          <a:p/>
+          <a:p>
+            <a:r>
+              <a:t>Frauen haben ihre grossen Gewichte genau bei den tiefen Quoten. Um diesen Effekt auszuschalten, haben wir für beide Geschlechter dieselben Gewichte eingesetzt, nämlich die Verteilung aller 4 526 Bewerbungen.</a:t>
+            </a:r>
+          </a:p>
+          <a:p/>
+          <a:p>
+            <a:r>
+              <a:t>Das Ergebnis sehen Sie rechts: Frauen 43.0 Prozent, Männer 38.7 Prozent. Der Unterschied kehrt sich also um.</a:t>
+            </a:r>
+          </a:p>
+          <a:p/>
+          <a:p>
+            <a:r>
+              <a:t>Im Code ist das eine einzige Zeile: Die Funktion gesamtquote multipliziert Quoten und Anteile und summiert. Für die Standardisierung rufen wir sie nur mit anderen Gewichten auf.</a:t>
+            </a:r>
+          </a:p>
+          <a:p/>
+          <a:p>
+            <a:r>
+              <a:t>Merksatz: Die Gesamtquote ist ein gewichteter Mittelwert. Die Gewichte, also die Fachbereichswahl, erzeugen den Unterschied.</a:t>
+            </a:r>
+          </a:p>
+          <a:p/>
+          <a:p>
+            <a:r>
+              <a:t>[Ergänzung für 20 Minuten] Die gemeinsamen Gewichte sind die Anteile aller Bewerbungen je Fachbereich: A 20.6 %, B 12.9 %, C 20.3 %, D 17.5 %, E 12.9 % und F 15.8 %.</a:t>
+            </a:r>
           </a:p>
         </p:txBody>
       </p:sp>
@@ -2706,10 +2822,50 @@
           <a:lstStyle/>
           <a:p>
             <a:r>
-              <a:rPr lang="en-US" dirty="0"/>
-              <a:t>Filip Lazic. Jetzt zur stochastischen Unabhängigkeit, wie im Folienskript Teil 3. Z heisst zugelassen, W heisst Bewerbung einer Frau. Unabhängig wären die beiden, wenn P von Z geschnitten W gleich P von Z mal P von W ist, genau wie im Beispiel mit Navi und Klimaanlage. Aus der Kreuztabelle: P von Z ist 0.388, P von W 0.405, das Produkt 0.157. Beobachtet ist aber nur 0.123, rund 22 Prozent weniger. Über alle Fachbereiche zusammen sind Zulassung und Geschlecht also stochastisch abhängig.</a:t>
-            </a:r>
-            <a:endParaRPr lang="en-US" dirty="0"/>
+              <a:t>Filip Lazic · 11:40–12:50</a:t>
+            </a:r>
+          </a:p>
+          <a:p/>
+          <a:p>
+            <a:r>
+              <a:t>Nun zur stochastischen Unabhängigkeit, wie im Folienskript Teil 3. Z steht für «zugelassen», W für «Bewerbung einer Frau». Die Zulassungsquoten von vorhin sind bedingte Wahrscheinlichkeiten, zum Beispiel P von Z gegeben W.</a:t>
+            </a:r>
+          </a:p>
+          <a:p/>
+          <a:p>
+            <a:r>
+              <a:t>Zwei Ereignisse sind stochastisch unabhängig, wenn das eine die Wahrscheinlichkeit des anderen nicht verändert. Formal gilt dann: P von Z geschnitten W gleich P von Z mal P von W. Wir prüfen das genau wie im Beispiel mit Navi und Klimaanlage.</a:t>
+            </a:r>
+          </a:p>
+          <a:p/>
+          <a:p>
+            <a:r>
+              <a:t>Aus der Kreuztabelle ergibt sich P von Z gleich 0.388 und P von W gleich 0.405. Bei Unabhängigkeit müsste P von Z geschnitten W also 0.157 sein. Beobachtet sind aber nur 0.123, rund 22 Prozent weniger.</a:t>
+            </a:r>
+          </a:p>
+          <a:p/>
+          <a:p>
+            <a:r>
+              <a:t>Über alle Fachbereiche zusammen sind Zulassung und Geschlecht damit stochastisch abhängig.</a:t>
+            </a:r>
+          </a:p>
+          <a:p/>
+          <a:p>
+            <a:r>
+              <a:t>Im Code berechnet das die Funktion pruefe_unabhaengigkeit. Sie gibt alle Kennzahlen als Dictionary zurück, damit man sie über ihren Namen ansprechen kann.</a:t>
+            </a:r>
+          </a:p>
+          <a:p/>
+          <a:p>
+            <a:r>
+              <a:t>Merksatz: Gesamt: 0.123 statt 0.157, also abhängig.</a:t>
+            </a:r>
+          </a:p>
+          <a:p/>
+          <a:p>
+            <a:r>
+              <a:t>[Ergänzung für 20 Minuten] Zur Kontrolle ergibt P(Z ∩ W) geteilt durch P(W) = 0.1231 / 0.4054 = 0.304, also genau die Zulassungsquote der Frauen.</a:t>
+            </a:r>
           </a:p>
         </p:txBody>
       </p:sp>
@@ -2794,10 +2950,44 @@
           <a:lstStyle/>
           <a:p>
             <a:r>
-              <a:rPr lang="en-US" dirty="0"/>
-              <a:t>Filip Lazic. Dieselbe Prüfung machen wir in jedem Fachbereich, im Code mit dem Generator, der Fachbereich für Fachbereich liefert. Links die Differenz der Quoten: In B bis F sind es höchstens 5 Prozentpunkte, und die Richtung wechselt. Rechts liegen P von Z geschnitten W und das Produkt nahe beieinander. Bei B beruht das auf nur 25 Bewerbungen von Frauen. Innerhalb der Fachbereiche sind Zulassung und Geschlecht also annähernd unabhängig. Die einzige deutliche Abweichung ist Fachbereich A, und die geht zugunsten der Frauen. Ob die kleinen Abweichungen zufällig sind, liesse sich mit einem Hypothesentest prüfen, der kommt im Kurs später.</a:t>
-            </a:r>
-            <a:endParaRPr lang="en-US" dirty="0"/>
+              <a:t>Filip Lazic · 12:50–14:00</a:t>
+            </a:r>
+          </a:p>
+          <a:p/>
+          <a:p>
+            <a:r>
+              <a:t>Dieselbe Prüfung haben wir für jeden Fachbereich gemacht. Im Code liefert der Generator die Ergebnisse Fachbereich für Fachbereich.</a:t>
+            </a:r>
+          </a:p>
+          <a:p/>
+          <a:p>
+            <a:r>
+              <a:t>Links sehen Sie die Differenz der Quoten. In B bis F beträgt sie höchstens 5 Prozentpunkte, und die Richtung wechselt: In B, D und F liegen die Frauen vorne, in C und E die Männer. Bei B beruht das zudem auf nur 25 Bewerbungen von Frauen.</a:t>
+            </a:r>
+          </a:p>
+          <a:p/>
+          <a:p>
+            <a:r>
+              <a:t>Rechts liegen P von Z geschnitten W und das Produkt jeweils nahe beieinander. Innerhalb der Fachbereiche sind Zulassung und Geschlecht also annähernd unabhängig.</a:t>
+            </a:r>
+          </a:p>
+          <a:p/>
+          <a:p>
+            <a:r>
+              <a:t>Die einzige deutliche Abweichung ist Fachbereich A, und die geht zugunsten der Frauen.</a:t>
+            </a:r>
+          </a:p>
+          <a:p/>
+          <a:p>
+            <a:r>
+              <a:t>Wichtig: Unsere Beurteilung ist beschreibend. Ob kleine Abweichungen zufällig sind, würde ein Hypothesentest klären. Den behandeln wir im Kurs erst später.</a:t>
+            </a:r>
+          </a:p>
+          <a:p/>
+          <a:p>
+            <a:r>
+              <a:t>Merksatz: Insgesamt abhängig, innerhalb der Fachbereiche annähernd unabhängig.</a:t>
+            </a:r>
           </a:p>
         </p:txBody>
       </p:sp>
@@ -2882,10 +3072,26 @@
           <a:lstStyle/>
           <a:p>
             <a:r>
-              <a:rPr lang="en-US" dirty="0"/>
-              <a:t>Filip Lazic. Das ist die Kernaussage unserer Analyse. Nicht die Zulassungsentscheide innerhalb der Fachbereiche erzeugen den Unterschied, sondern die Drittvariable Fachbereich. Frauen bewarben sich häufiger dort, wo es schwer ist. Wenn man die Fachbereiche zusammenfasst, kehrt sich der Zusammenhang um. Dieses Phänomen heisst Simpson-Paradoxon, und die Berkeley-Daten werden häufig verwendet, um es zu veranschaulichen.</a:t>
-            </a:r>
-            <a:endParaRPr lang="en-US" dirty="0"/>
+              <a:t>Filip Lazic · 14:00–14:30</a:t>
+            </a:r>
+          </a:p>
+          <a:p/>
+          <a:p>
+            <a:r>
+              <a:t>Damit sind wir bei der Kernaussage: Der Fachbereich erklärt den Unterschied.</a:t>
+            </a:r>
+          </a:p>
+          <a:p/>
+          <a:p>
+            <a:r>
+              <a:t>Frauen bewarben sich häufiger in stark umkämpften Fachbereichen. Fasst man die Fachbereiche zusammen, kehrt sich der Zusammenhang um. Dieses Phänomen heisst nach Edward Simpson das Simpson-Paradoxon. Die Berkeley-Daten werden häufig verwendet, um es zu veranschaulichen.</a:t>
+            </a:r>
+          </a:p>
+          <a:p/>
+          <a:p>
+            <a:r>
+              <a:t>Merksatz: Eine Drittvariable, hier der Fachbereich, kann einen Zusammenhang beim Zusammenfassen umkehren.</a:t>
+            </a:r>
           </a:p>
         </p:txBody>
       </p:sp>
@@ -2970,10 +3176,44 @@
           <a:lstStyle/>
           <a:p>
             <a:r>
-              <a:rPr lang="en-US" dirty="0"/>
-              <a:t>Filip Lazic. Drei Punkte zum Mitnehmen. Erstens: Über alle Fachbereiche zusammen sind Zulassung und Geschlecht abhängig. Zweitens: Innerhalb der Fachbereiche gibt es keinen systematischen Nachteil für Frauen, in Fachbereich A liegen sie sogar deutlich vorne. Drittens: Die Ursache ist die Wahl des Fachbereichs. Bei gleicher Wahl läge die Quote der Frauen sogar höher. Grenzen: Es sind Beobachtungsdaten eines Jahres, und warum Frauen die selektiveren Fachbereiche wählten, sagen die Daten nicht. Und programmtechnisch: Dank Funktionen konnten wir denselben Code für alle Teilanalysen verwenden. Vielen Dank, wir freuen uns auf Fragen.</a:t>
-            </a:r>
-            <a:endParaRPr lang="en-US" dirty="0"/>
+              <a:t>Filip Lazic · 14:30–15:10</a:t>
+            </a:r>
+          </a:p>
+          <a:p/>
+          <a:p>
+            <a:r>
+              <a:t>Drei Punkte zum Mitnehmen. Erstens: Über alle Fachbereiche zusammen sind Zulassung und Geschlecht abhängig, 30.4 gegen 44.5 Prozent.</a:t>
+            </a:r>
+          </a:p>
+          <a:p/>
+          <a:p>
+            <a:r>
+              <a:t>Zweitens: In den Fachbereichen zeigt sich kein systematischer Nachteil für Frauen, in Fachbereich A liegen sie sogar deutlich vorne.</a:t>
+            </a:r>
+          </a:p>
+          <a:p/>
+          <a:p>
+            <a:r>
+              <a:t>Drittens: Die Ursache ist die Wahl des Fachbereichs. Bei gleicher Wahl läge die Quote der Frauen bei 43.0, die der Männer bei 38.7 Prozent.</a:t>
+            </a:r>
+          </a:p>
+          <a:p/>
+          <a:p>
+            <a:r>
+              <a:t>Unsere Analyse hat auch Grenzen. Es sind Beobachtungsdaten eines einzigen Jahres. Warum Frauen die selektiveren Fachbereiche wählten und wie qualifiziert die Bewerbenden waren, sagen die Daten nicht.</a:t>
+            </a:r>
+          </a:p>
+          <a:p/>
+          <a:p>
+            <a:r>
+              <a:t>Und programmtechnisch: Dank Funktionen konnten wir denselben Code für die Gesamtanalyse, alle sechs Fachbereiche und die Standardisierung verwenden.</a:t>
+            </a:r>
+          </a:p>
+          <a:p/>
+          <a:p>
+            <a:r>
+              <a:t>Merksatz: Abhängig insgesamt, kein systematischer Nachteil je Fachbereich, Ursache ist die Fachbereichswahl.</a:t>
+            </a:r>
           </a:p>
         </p:txBody>
       </p:sp>
@@ -3058,10 +3298,14 @@
           <a:lstStyle/>
           <a:p>
             <a:r>
-              <a:rPr lang="en-US" dirty="0"/>
-              <a:t>Alle. Hier unsere Quellen nach APA 7. Danach Fragen aus dem Publikum.</a:t>
-            </a:r>
-            <a:endParaRPr lang="en-US" dirty="0"/>
+              <a:t>Filip Lazic · 15:10–15:20</a:t>
+            </a:r>
+          </a:p>
+          <a:p/>
+          <a:p>
+            <a:r>
+              <a:t>Vielen Dank für Ihre Aufmerksamkeit. Rechts finden Sie unsere Quellen. Wir freuen uns auf Ihre Fragen.</a:t>
+            </a:r>
           </a:p>
         </p:txBody>
       </p:sp>
@@ -3146,10 +3390,32 @@
           <a:lstStyle/>
           <a:p>
             <a:r>
-              <a:rPr lang="en-US" dirty="0"/>
-              <a:t>Leorat Krasniqi. 1973 gingen an den sechs grössten Fachbereichen der UC Berkeley 4 526 Bewerbungen ein. Von den Männern wurden 44.5 Prozent zugelassen, von den Frauen nur 30.4 Prozent. Die naheliegende Frage: Werden Frauen benachteiligt? Bickel und Kollegen haben genau das 1975 untersucht. Wir schauen uns die Daten mit Python an.</a:t>
-            </a:r>
-            <a:endParaRPr lang="en-US" dirty="0"/>
+              <a:t>Leorat Krasniqi · 0:30–1:20</a:t>
+            </a:r>
+          </a:p>
+          <a:p/>
+          <a:p>
+            <a:r>
+              <a:t>1973 gingen an den sechs grössten Fachbereichen der UC Berkeley 4 526 Bewerbungen für ein Graduate-Studium ein.</a:t>
+            </a:r>
+          </a:p>
+          <a:p/>
+          <a:p>
+            <a:r>
+              <a:t>Von den Männern wurden 44.5 Prozent zugelassen, also 1 198 von 2 691. Von den Frauen waren es nur 30.4 Prozent, 557 von 1 835.</a:t>
+            </a:r>
+          </a:p>
+          <a:p/>
+          <a:p>
+            <a:r>
+              <a:t>Die naheliegende Frage steht unten auf der Folie: Werden Frauen im Zulassungsverfahren benachteiligt? Genau diese Frage haben Bickel und Kollegen 1975 in der Zeitschrift Science untersucht. Wir gehen ihr mit Python nach.</a:t>
+            </a:r>
+          </a:p>
+          <a:p/>
+          <a:p>
+            <a:r>
+              <a:t>Merksatz: 44.5 % gegenüber 30.4 %: Auf den ersten Blick sieht das nach Benachteiligung aus.</a:t>
+            </a:r>
           </a:p>
         </p:txBody>
       </p:sp>
@@ -3234,10 +3500,32 @@
           <a:lstStyle/>
           <a:p>
             <a:r>
-              <a:rPr lang="en-US" dirty="0"/>
-              <a:t>Leorat Krasniqi. Unsere Aufgabe hat drei Teile. In (a) erklären wir Funktionen in Python nach McKinney, Abschnitt 3.2, und zeigen, wo wir sie im eigenen Code verwenden. In (b) stellen wir die Zahlen so dar, dass man die Ungerechtigkeit sofort sieht. In (c) schauen wir genauer hin, vergleichen die Verteilungen und prüfen die stochastische Unabhängigkeit.</a:t>
-            </a:r>
-            <a:endParaRPr lang="en-US" dirty="0"/>
+              <a:t>Leorat Krasniqi · 1:20–1:50</a:t>
+            </a:r>
+          </a:p>
+          <a:p/>
+          <a:p>
+            <a:r>
+              <a:t>Unsere Aufgabe hat drei Teile. In Teil a erkläre ich Funktionen in Python nach McKinney, Abschnitt 3.2, und zeige, wo wir sie im eigenen Code einsetzen.</a:t>
+            </a:r>
+          </a:p>
+          <a:p/>
+          <a:p>
+            <a:r>
+              <a:t>In Teil b zeigt Teoman unsere Vorüberlegungen und ein Diagramm, aus dem man die scheinbare Ungerechtigkeit sofort sieht.</a:t>
+            </a:r>
+          </a:p>
+          <a:p/>
+          <a:p>
+            <a:r>
+              <a:t>In Teil c schauen Teoman und Filip genauer hin: Sie vergleichen die Verteilungen und prüfen die stochastische Unabhängigkeit.</a:t>
+            </a:r>
+          </a:p>
+          <a:p/>
+          <a:p>
+            <a:r>
+              <a:t>Merksatz: a = Funktionen, b = Darstellung, c = Vergleich und Unabhängigkeit.</a:t>
+            </a:r>
           </a:p>
         </p:txBody>
       </p:sp>
@@ -3322,10 +3610,14 @@
           <a:lstStyle/>
           <a:p>
             <a:r>
-              <a:rPr lang="en-US" dirty="0"/>
-              <a:t>Leorat Krasniqi. Wir beginnen mit Aufgabe (a): Funktionen in Python.</a:t>
-            </a:r>
-            <a:endParaRPr lang="en-US" dirty="0"/>
+              <a:t>Leorat Krasniqi · 1:50–2:00</a:t>
+            </a:r>
+          </a:p>
+          <a:p/>
+          <a:p>
+            <a:r>
+              <a:t>Wir beginnen mit Teil a: Funktionen in Python.</a:t>
+            </a:r>
           </a:p>
         </p:txBody>
       </p:sp>
@@ -3410,10 +3702,56 @@
           <a:lstStyle/>
           <a:p>
             <a:r>
-              <a:rPr lang="en-US" dirty="0"/>
-              <a:t>Leorat Krasniqi. McKinney nennt Funktionen die wichtigste Methode, um Code zu organisieren und wiederzuverwenden. Faustregel: Was man mehr als einmal braucht, gehört in eine Funktion. Funktionen werden mit def deklariert und mit return verlassen. Positionsargumente werden über die Reihenfolge zugeordnet, Keyword-Argumente über den Namen, oft mit Standardwert. Rechts unser Beispiel: kreuztabelle hat das Keyword-Argument fachbereich mit Standardwert None, ohne Angabe gilt die Tabelle für alle Fachbereiche. Variablen in einer Funktion leben nur während des Aufrufs, global vermeiden wir. Mehrere Rückgabewerte sind eigentlich ein Tupel, das wir direkt entpacken, wie bei kennzahlen.</a:t>
-            </a:r>
-            <a:endParaRPr lang="en-US" dirty="0"/>
+              <a:t>Leorat Krasniqi · 2:00–3:40</a:t>
+            </a:r>
+          </a:p>
+          <a:p/>
+          <a:p>
+            <a:r>
+              <a:t>Laut McKinney sind Funktionen die wichtigste Methode, um Code in Python zu organisieren und wiederzuverwenden. Sie machen Code ausserdem lesbarer, weil sie einer Gruppe von Anweisungen einen Namen geben.</a:t>
+            </a:r>
+          </a:p>
+          <a:p/>
+          <a:p>
+            <a:r>
+              <a:t>Links sehen Sie die vier Grundlagen. Erstens: Eine Funktion wird mit def deklariert und mit return verlassen. Fehlt das return, gibt Python automatisch None zurück.</a:t>
+            </a:r>
+          </a:p>
+          <a:p/>
+          <a:p>
+            <a:r>
+              <a:t>Zweitens gibt es Positions- und Keyword-Argumente. Positionsargumente werden über ihre Reihenfolge zugeordnet, Keyword-Argumente über ihren Namen. Keyword-Argumente haben oft einen Standardwert und müssen immer nach den Positionsargumenten stehen.</a:t>
+            </a:r>
+          </a:p>
+          <a:p/>
+          <a:p>
+            <a:r>
+              <a:t>Rechts sehen Sie das in unserem Code. Die Funktion kreuztabelle hat das Keyword-Argument fachbereich mit dem Standardwert None. Ruft man sie ohne diese Angabe auf, erstellt sie die Kreuztabelle über alle Bewerbungen. Mit fachbereich gleich A filtert sie zuerst die Zeilen von Fachbereich A. pivot_table aus pandas fasst die Anzahlen dann zu einer Tabelle Geschlecht mal Entscheid zusammen. Eine einzige Funktion reicht so für die Gesamtbetrachtung und für alle sechs Fachbereiche.</a:t>
+            </a:r>
+          </a:p>
+          <a:p/>
+          <a:p>
+            <a:r>
+              <a:t>Drittens der Namensraum: Variablen in einer Funktion leben nur während des Aufrufs. McKinney rät von global ab, deshalb bekommen alle unsere Funktionen ihre Daten als Argument.</a:t>
+            </a:r>
+          </a:p>
+          <a:p/>
+          <a:p>
+            <a:r>
+              <a:t>Viertens: Gibt eine Funktion scheinbar mehrere Werte zurück, ist das eigentlich ein Tupel. Unsere Funktion kennzahlen liefert Quote und Anteil, und wir entpacken beide direkt in zwei Variablen.</a:t>
+            </a:r>
+          </a:p>
+          <a:p/>
+          <a:p>
+            <a:r>
+              <a:t>Merksatz: def, return, Keyword-Argument mit Standardwert: Eine Funktion ersetzt sieben Kopien desselben Codes.</a:t>
+            </a:r>
+          </a:p>
+          <a:p/>
+          <a:p>
+            <a:r>
+              <a:t>[Ergänzung für 20 Minuten] Statt eines Tupels kann man auch ein Dictionary zurückgeben. Das machen wir in pruefe_unabhaengigkeit, weil sie neun Kennzahlen liefert, die man so über ihren Namen ansprechen kann (McKinney, S. 74).</a:t>
+            </a:r>
           </a:p>
         </p:txBody>
       </p:sp>
@@ -3498,10 +3836,56 @@
           <a:lstStyle/>
           <a:p>
             <a:r>
-              <a:rPr lang="en-US" dirty="0"/>
-              <a:t>Leorat Krasniqi. Weil Funktionen in Python Objekte sind, können wir sie in eine Liste packen: So bereinigen wir die Prozentangaben aus Tabelle 4, Schritt für Schritt, genau wie McKinneys clean_strings. Lambda-Funktionen sind Einzeiler, die wir zum Beispiel für die Achsenbeschriftung übergeben. Mit partial leiten wir aus der allgemeinen Funktion bedingte_quote die Zulassungsquote der Frauen ab. Der Generator mit yield liefert die Ergebnisse Fachbereich für Fachbereich. Und bei der Fehlerbehandlung fangen wir nur den ValueError ab, damit ein Tippfehler in der Tabelle auffällt. Damit übergebe ich an Teoman.</a:t>
-            </a:r>
-            <a:endParaRPr lang="en-US" dirty="0"/>
+              <a:t>Leorat Krasniqi · 3:40–5:10</a:t>
+            </a:r>
+          </a:p>
+          <a:p/>
+          <a:p>
+            <a:r>
+              <a:t>Links steht McKinneys Faustregel: Code, den man mehr als einmal braucht, gehört in eine Funktion. Rechts sehen Sie fünf weitere Konzepte aus Abschnitt 3.2, jeweils mit einer Zeile aus unserem Code.</a:t>
+            </a:r>
+          </a:p>
+          <a:p/>
+          <a:p>
+            <a:r>
+              <a:t>Erstens sind Funktionen in Python Objekte. Man kann sie deshalb in eine Liste packen. Genau so bereinigen wir die Werte aus Tabelle 4: Leerzeichen entfernen, Prozentzeichen entfernen, in eine Zahl umwandeln. Das ist dasselbe Muster wie McKinneys clean_strings.</a:t>
+            </a:r>
+          </a:p>
+          <a:p/>
+          <a:p>
+            <a:r>
+              <a:t>Zweitens Lambda-Funktionen: anonyme Einzeiler. Wir übergeben sie zum Beispiel, um Achsen in Prozent zu beschriften.</a:t>
+            </a:r>
+          </a:p>
+          <a:p/>
+          <a:p>
+            <a:r>
+              <a:t>Drittens Currying mit partial: Aus der allgemeinen Funktion bedingte_quote machen wir quote_frauen, indem wir das Geschlecht fest einsetzen. Das Ergebnis ist P von Z gegeben W.</a:t>
+            </a:r>
+          </a:p>
+          <a:p/>
+          <a:p>
+            <a:r>
+              <a:t>Viertens ein Generator mit yield: Er liefert die Ergebnisse Fachbereich für Fachbereich, und zwar erst dann, wenn sie gebraucht werden.</a:t>
+            </a:r>
+          </a:p>
+          <a:p/>
+          <a:p>
+            <a:r>
+              <a:t>Und fünftens die Fehlerbehandlung: Wir fangen nur den ValueError ab. Ein Tippfehler in der Tabelle bricht dann mit einer klaren Meldung ab, statt dass wir unbemerkt mit einer falschen Zahl weiterrechnen.</a:t>
+            </a:r>
+          </a:p>
+          <a:p/>
+          <a:p>
+            <a:r>
+              <a:t>Damit übergebe ich an Teoman.</a:t>
+            </a:r>
+          </a:p>
+          <a:p/>
+          <a:p>
+            <a:r>
+              <a:t>Merksatz: Alle Konzepte aus Abschnitt 3.2 kommen in unserem eigenen Code vor, nicht nur in Beispielen.</a:t>
+            </a:r>
           </a:p>
         </p:txBody>
       </p:sp>
@@ -3586,10 +3970,14 @@
           <a:lstStyle/>
           <a:p>
             <a:r>
-              <a:rPr lang="en-US" dirty="0"/>
-              <a:t>Teoman-Doganay Lam. Weiter mit unseren Vorüberlegungen und Aufgabe (b).</a:t>
-            </a:r>
-            <a:endParaRPr lang="en-US" dirty="0"/>
+              <a:t>Teoman-Doganay Lam · 5:10–5:20</a:t>
+            </a:r>
+          </a:p>
+          <a:p/>
+          <a:p>
+            <a:r>
+              <a:t>Danke, Leorat. Bevor wir zu Teil b kommen, zeige ich, wie wir die Umsetzung geplant haben.</a:t>
+            </a:r>
           </a:p>
         </p:txBody>
       </p:sp>
@@ -3674,10 +4062,56 @@
           <a:lstStyle/>
           <a:p>
             <a:r>
-              <a:rPr lang="en-US" dirty="0"/>
-              <a:t>Teoman-Doganay Lam. Bevor wir programmiert haben, haben wir uns überlegt, was vorliegt. Tabelle 4 enthält nur Prozente. Wir erfassen sie wortgetreu als Text und bereinigen sie mit einer Liste von Funktionen. Für die Unabhängigkeit brauchen wir aber Anzahlen. Die nehmen wir aus dem Originaldatensatz, den es in R als UCBAdmissions gibt, und prüfen per Code, dass sie alle 24 Prozentwerte der Tabelle ergeben: null Abweichungen. Dann bilden wir Kreuztabellen, gesamt und je Fachbereich, und zeichnen die Diagramme, die wir im Kurs kennengelernt haben. Libraries: pandas für Tabellen, numpy zum Rechnen, matplotlib für Diagramme, alle in Anaconda enthalten.</a:t>
-            </a:r>
-            <a:endParaRPr lang="en-US" dirty="0"/>
+              <a:t>Teoman-Doganay Lam · 5:20–6:50</a:t>
+            </a:r>
+          </a:p>
+          <a:p/>
+          <a:p>
+            <a:r>
+              <a:t>Die erste Frage war: Was liegt eigentlich vor? Tabelle 4 enthält nur Prozentwerte, also Zulassungsquoten und Anteile. Daraus ergeben sich unsere fünf Schritte.</a:t>
+            </a:r>
+          </a:p>
+          <a:p/>
+          <a:p>
+            <a:r>
+              <a:t>Schritt 1 und 2: Wir erfassen Tabelle 4 wortgetreu als Text, zum Beispiel «82.4%», und machen mit der Liste von Funktionen, die Leorat gezeigt hat, Zahlen daraus. So bleibt die Datenerfassung nachvollziehbar.</a:t>
+            </a:r>
+          </a:p>
+          <a:p/>
+          <a:p>
+            <a:r>
+              <a:t>Schritt 3 ist der wichtigste: Für die stochastische Unabhängigkeit brauchen wir Anzahlen, zum Beispiel wie viele Frauen es insgesamt waren. Aus den gerundeten Prozenten lassen sie sich nicht exakt zurückrechnen. Wir übernehmen sie deshalb aus dem Originaldatensatz, der in R als UCBAdmissions verfügbar ist. Der Code prüft, dass diese Anzahlen alle 24 Prozentwerte der Tabelle ergeben. Das Ergebnis sind null Abweichungen.</a:t>
+            </a:r>
+          </a:p>
+          <a:p/>
+          <a:p>
+            <a:r>
+              <a:t>Schritt 4: Die Daten liegen als eine lange Tabelle vor, mit einer Zeile pro Fachbereich, Geschlecht und Entscheid. Daraus bildet die Funktion kreuztabelle jede Tabelle, die wir brauchen.</a:t>
+            </a:r>
+          </a:p>
+          <a:p/>
+          <a:p>
+            <a:r>
+              <a:t>Schritt 5: Als Diagrammtypen verwenden wir die aus dem Kurs, also Säulen- und Balkendiagramme für Kreuztabellen und im Notebook zusätzlich ein Streudiagramm.</a:t>
+            </a:r>
+          </a:p>
+          <a:p/>
+          <a:p>
+            <a:r>
+              <a:t>Unten stehen die Libraries und warum wir sie gewählt haben. pandas ist das Standardwerkzeug für Tabellen, eine Kreuztabelle entsteht damit in einer Zeile. numpy rechnet auf ganzen Spalten ohne Schleifen. matplotlib gibt uns volle Kontrolle über Farben und Beschriftungen. re und functools stammen aus der Standardbibliothek. Alle diese Libraries sind in Anaconda enthalten, das wir im Kurs verwenden.</a:t>
+            </a:r>
+          </a:p>
+          <a:p/>
+          <a:p>
+            <a:r>
+              <a:t>Merksatz: Erst prüfen, dann rechnen: Die Anzahlen reproduzieren Tabelle 4 ohne eine einzige Abweichung.</a:t>
+            </a:r>
+          </a:p>
+          <a:p/>
+          <a:p>
+            <a:r>
+              <a:t>[Ergänzung für 20 Minuten] Als Plausibilitätskontrolle rechnet der Code auch die Zeile «Total» aus den Fachbereichswerten nach. Das ergibt 30.4 und 44.6 Prozent, die Differenz von 0.1 zur Tabelle entsteht nur durch Rundung.</a:t>
+            </a:r>
           </a:p>
         </p:txBody>
       </p:sp>
@@ -3762,10 +4196,44 @@
           <a:lstStyle/>
           <a:p>
             <a:r>
-              <a:rPr lang="en-US" dirty="0"/>
-              <a:t>Teoman-Doganay Lam. Für Aufgabe (b) soll man auf einen Blick sehen, warum das Verfahren ungerecht wirkt. Dafür reicht ein einziger Vergleich: die Zulassungsquote aller Frauen gegen die aller Männer. Ein Balkendiagramm mit Nullachse, Werte direkt an den Balken, keine Ablenkung. 30.4 gegen 44.5 Prozent, also 14.2 Prozentpunkte weniger für Frauen; exakt gerechnet 44.52 minus 30.35. Anders gesagt: Mit der Männerquote wären 817 statt 557 Frauen zugelassen worden. Die Frage ist: Ist das Diskriminierung?</a:t>
-            </a:r>
-            <a:endParaRPr lang="en-US" dirty="0"/>
+              <a:t>Teoman-Doganay Lam · 6:50–8:00</a:t>
+            </a:r>
+          </a:p>
+          <a:p/>
+          <a:p>
+            <a:r>
+              <a:t>Teil b verlangt eine Darstellung, aus der man die Ungerechtigkeit schnell erkennt. Dafür reicht ein einziger Vergleich: die Zulassungsquote aller Frauen gegen die aller Männer.</a:t>
+            </a:r>
+          </a:p>
+          <a:p/>
+          <a:p>
+            <a:r>
+              <a:t>Wir haben bewusst ein einfaches Balkendiagramm gewählt, mit Nullachse, damit die Längen ehrlich vergleichbar sind, und mit den Werten direkt an den Balken. Die Farben bleiben in der ganzen Präsentation gleich: Orange für Frauen, Blau für Männer.</a:t>
+            </a:r>
+          </a:p>
+          <a:p/>
+          <a:p>
+            <a:r>
+              <a:t>Das Ergebnis: 30.4 gegen 44.5 Prozent, also 14.2 Prozentpunkte weniger für Frauen. Exakt gerechnet sind es 44.52 minus 30.35. Die Quote der Männer ist damit fast 1.5-mal so hoch. Anders gesagt: Mit der Quote der Männer wären 817 statt 557 Frauen zugelassen worden.</a:t>
+            </a:r>
+          </a:p>
+          <a:p/>
+          <a:p>
+            <a:r>
+              <a:t>Im Code übernimmt matplotlib das Zeichnen. Die Werte schreibt unsere Funktion saeulen_beschriften an die Säulen. Ihr übergeben wir die Formatierung als Funktion, wieder ein Konzept aus Teil a.</a:t>
+            </a:r>
+          </a:p>
+          <a:p/>
+          <a:p>
+            <a:r>
+              <a:t>Also Diskriminierung? Genau diesen Schluss prüfen wir jetzt.</a:t>
+            </a:r>
+          </a:p>
+          <a:p/>
+          <a:p>
+            <a:r>
+              <a:t>Merksatz: Aggregiert: 14.2 Prozentpunkte weniger für Frauen. Die Frage ist, ob dieser Schluss hält.</a:t>
+            </a:r>
           </a:p>
         </p:txBody>
       </p:sp>

</xml_diff>

<commit_message>
Sprechtext verständlicher: Alltagsvergleiche, weniger Fachjargon, Begriffsliste
Co-Authored-By: Claude Opus 5.5 <noreply@anthropic.com>
Claude-Session: https://claude.ai/code/session_013vrRC9ggswsEWMp2ebeFzZ
</commit_message>
<xml_diff>
--- a/vortrag4/Vortrag4_Praesentation.pptx
+++ b/vortrag4/Vortrag4_Praesentation.pptx
@@ -2596,7 +2596,7 @@
           <a:p/>
           <a:p>
             <a:r>
-              <a:t>Rechts sieht man den Zusammenhang über alle sechs Fachbereiche: Die Korrelation zwischen Frauenanteil und Zulassungsquote beträgt minus 0.79. Zwei Beispiele: In A sind 11.6 Prozent der Bewerbungen von Frauen, die Quote liegt bei 64.4 Prozent. In E sind es 67.3 Prozent Frauen, und die Quote liegt nur bei 25.2 Prozent.</a:t>
+              <a:t>Rechts sieht man das für alle sechs Fachbereiche: Je höher der Frauenanteil, desto tiefer die Zulassungsquote. Die Korrelation beträgt minus 0.79. Minus heisst «je mehr, desto weniger», und 0.79 ist nahe bei 1, also ein starker Zusammenhang. Zwei Beispiele: In A sind 11.6 Prozent der Bewerbungen von Frauen, die Quote liegt bei 64.4 Prozent. In E sind es 67.3 Prozent Frauen, und die Quote liegt nur bei 25.2 Prozent.</a:t>
             </a:r>
           </a:p>
           <a:p/>
@@ -2706,19 +2706,19 @@
           <a:p/>
           <a:p>
             <a:r>
-              <a:t>Die Formel oben sagt: Die Zulassungsquote eines Geschlechts ist die Summe über alle Fachbereiche, und zwar Anteil der Bewerbungen mal Quote im Fachbereich. Die Gesamtquote ist also ein gewichteter Mittelwert. Die Gewichte sind die Anteile, also wo man sich beworben hat.</a:t>
+              <a:t>Die Formel oben sagt: Man nimmt für jeden Fachbereich den Anteil der Bewerbungen mal die Quote dort und zählt alles zusammen. Das kennen Sie vom Notenschnitt: Ein Modul mit vielen ECTS zählt mehr als eines mit wenigen. Hier zählt ein Fachbereich mehr, je mehr Bewerbungen dort eingingen.</a:t>
             </a:r>
           </a:p>
           <a:p/>
           <a:p>
             <a:r>
-              <a:t>Frauen haben ihre grossen Gewichte genau bei den tiefen Quoten. Um diesen Effekt auszuschalten, haben wir für beide Geschlechter dieselben Gewichte eingesetzt, nämlich die Verteilung aller 4 526 Bewerbungen.</a:t>
+              <a:t>Bei den Frauen zählen also genau die Fachbereiche mit tiefen Quoten am meisten. Das drückt ihren Schnitt nach unten. Deshalb haben wir gerechnet, als hätten sich Frauen und Männer genau gleich auf die Fachbereiche verteilt, nämlich so wie alle 4 526 Bewerbungen zusammen.</a:t>
             </a:r>
           </a:p>
           <a:p/>
           <a:p>
             <a:r>
-              <a:t>Das Ergebnis sehen Sie rechts: Frauen 43.0 Prozent, Männer 38.7 Prozent. Der Unterschied kehrt sich also um.</a:t>
+              <a:t>Das Ergebnis sehen Sie rechts: Frauen 43.0 Prozent, Männer 38.7 Prozent. Bei gleicher Fachbereichswahl liegen also die Frauen vorne.</a:t>
             </a:r>
           </a:p>
           <a:p/>
@@ -2834,13 +2834,13 @@
           <a:p/>
           <a:p>
             <a:r>
-              <a:t>Zwei Ereignisse sind stochastisch unabhängig, wenn das eine die Wahrscheinlichkeit des anderen nicht verändert. Formal gilt dann: P von Z geschnitten W gleich P von Z mal P von W. Wir prüfen das genau wie im Beispiel mit Navi und Klimaanlage.</a:t>
+              <a:t>Unabhängig heisst ganz einfach: Das Geschlecht spielt für die Zulassung keine Rolle. Formal gilt dann: P von Z geschnitten W gleich P von Z mal P von W. Wir prüfen das genau wie im Beispiel mit Navi und Klimaanlage.</a:t>
             </a:r>
           </a:p>
           <a:p/>
           <a:p>
             <a:r>
-              <a:t>Aus der Kreuztabelle ergibt sich P von Z gleich 0.388 und P von W gleich 0.405. Bei Unabhängigkeit müsste P von Z geschnitten W also 0.157 sein. Beobachtet sind aber nur 0.123, rund 22 Prozent weniger.</a:t>
+              <a:t>In Worten: 38.8 Prozent aller Bewerbungen wurden zugelassen, 40.5 Prozent stammen von Frauen. Spielt das Geschlecht keine Rolle, müssten 38.8 Prozent von diesen 40.5 Prozent zugelassene Frauen sein, das sind 15.7 Prozent aller Bewerbungen. Tatsächlich sind es aber nur 12.3 Prozent, rund 22 Prozent weniger als erwartet.</a:t>
             </a:r>
           </a:p>
           <a:p/>
@@ -2852,7 +2852,7 @@
           <a:p/>
           <a:p>
             <a:r>
-              <a:t>Im Code berechnet das die Funktion pruefe_unabhaengigkeit. Sie gibt alle Kennzahlen als Dictionary zurück, damit man sie über ihren Namen ansprechen kann.</a:t>
+              <a:t>Im Code berechnet das die Funktion pruefe_unabhaengigkeit. Sie gibt alle Kennzahlen als Dictionary zurück, das ist wie ein Nachschlagewerk: Jede Zahl hat einen Namen, unter dem man sie findet.</a:t>
             </a:r>
           </a:p>
           <a:p/>
@@ -2968,7 +2968,7 @@
           <a:p/>
           <a:p>
             <a:r>
-              <a:t>Rechts liegen P von Z geschnitten W und das Produkt jeweils nahe beieinander. Innerhalb der Fachbereiche sind Zulassung und Geschlecht also annähernd unabhängig.</a:t>
+              <a:t>Rechts liegen der beobachtete und der erwartete Wert jeweils nahe beieinander. Innerhalb der Fachbereiche spielt das Geschlecht also kaum eine Rolle, Zulassung und Geschlecht sind annähernd unabhängig.</a:t>
             </a:r>
           </a:p>
           <a:p/>
@@ -3084,7 +3084,7 @@
           <a:p/>
           <a:p>
             <a:r>
-              <a:t>Frauen bewarben sich häufiger in stark umkämpften Fachbereichen. Fasst man die Fachbereiche zusammen, kehrt sich der Zusammenhang um. Dieses Phänomen heisst nach Edward Simpson das Simpson-Paradoxon. Die Berkeley-Daten werden häufig verwendet, um es zu veranschaulichen.</a:t>
+              <a:t>Frauen bewarben sich häufiger in stark umkämpften Fachbereichen. Schaut man jeden Fachbereich einzeln an, haben Frauen keinen Nachteil. Wirft man alle zusammen, sieht es plötzlich nach einem Nachteil aus. Dieses Phänomen heisst nach Edward Simpson das Simpson-Paradoxon. Die Berkeley-Daten werden häufig verwendet, um es zu veranschaulichen.</a:t>
             </a:r>
           </a:p>
           <a:p/>
@@ -3708,37 +3708,37 @@
           <a:p/>
           <a:p>
             <a:r>
-              <a:t>Laut McKinney sind Funktionen die wichtigste Methode, um Code in Python zu organisieren und wiederzuverwenden. Sie machen Code ausserdem lesbarer, weil sie einer Gruppe von Anweisungen einen Namen geben.</a:t>
+              <a:t>Eine Funktion kann man sich wie ein Rezept vorstellen: Man gibt Zutaten hinein, sie arbeitet immer dieselben Schritte ab und gibt ein Ergebnis zurück. Laut McKinney sind Funktionen deshalb die wichtigste Methode, um Code zu ordnen und wiederzuverwenden.</a:t>
             </a:r>
           </a:p>
           <a:p/>
           <a:p>
             <a:r>
-              <a:t>Links sehen Sie die vier Grundlagen. Erstens: Eine Funktion wird mit def deklariert und mit return verlassen. Fehlt das return, gibt Python automatisch None zurück.</a:t>
+              <a:t>Links sehen Sie die vier Grundlagen. Erstens: Mit def gibt man dem Rezept einen Namen, mit return gibt es das Ergebnis heraus.</a:t>
             </a:r>
           </a:p>
           <a:p/>
           <a:p>
             <a:r>
-              <a:t>Zweitens gibt es Positions- und Keyword-Argumente. Positionsargumente werden über ihre Reihenfolge zugeordnet, Keyword-Argumente über ihren Namen. Keyword-Argumente haben oft einen Standardwert und müssen immer nach den Positionsargumenten stehen.</a:t>
+              <a:t>Zweitens die Argumente, also die Zutaten. Man kann sie der Reihe nach übergeben oder mit ihrem Namen. Ein Argument mit Namen kann eine Voreinstellung haben: Gibt man nichts an, nimmt Python diesen Standardwert.</a:t>
             </a:r>
           </a:p>
           <a:p/>
           <a:p>
             <a:r>
-              <a:t>Rechts sehen Sie das in unserem Code. Die Funktion kreuztabelle hat das Keyword-Argument fachbereich mit dem Standardwert None. Ruft man sie ohne diese Angabe auf, erstellt sie die Kreuztabelle über alle Bewerbungen. Mit fachbereich gleich A filtert sie zuerst die Zeilen von Fachbereich A. pivot_table aus pandas fasst die Anzahlen dann zu einer Tabelle Geschlecht mal Entscheid zusammen. Eine einzige Funktion reicht so für die Gesamtbetrachtung und für alle sechs Fachbereiche.</a:t>
+              <a:t>Rechts sehen Sie das in unserem Code. Die Funktion kreuztabelle zählt, wie viele Frauen und Männer zugelassen und abgelehnt wurden. Das Argument fachbereich ist standardmässig leer. Ruft man sie ohne Angabe auf, zählt sie über alle Bewerbungen. Schreibt man fachbereich gleich A, zählt sie nur in Fachbereich A. Eine einzige Funktion reicht so für das Gesamtbild und alle sechs Fachbereiche.</a:t>
             </a:r>
           </a:p>
           <a:p/>
           <a:p>
             <a:r>
-              <a:t>Drittens der Namensraum: Variablen in einer Funktion leben nur während des Aufrufs. McKinney rät von global ab, deshalb bekommen alle unsere Funktionen ihre Daten als Argument.</a:t>
+              <a:t>Drittens: Was in einer Funktion passiert, bleibt in der Funktion. Ihre Variablen verschwinden nach dem Aufruf wieder. Deshalb geben wir jeder Funktion die Daten ausdrücklich mit, statt irgendwo global darauf zuzugreifen.</a:t>
             </a:r>
           </a:p>
           <a:p/>
           <a:p>
             <a:r>
-              <a:t>Viertens: Gibt eine Funktion scheinbar mehrere Werte zurück, ist das eigentlich ein Tupel. Unsere Funktion kennzahlen liefert Quote und Anteil, und wir entpacken beide direkt in zwei Variablen.</a:t>
+              <a:t>Viertens: Eine Funktion kann mehrere Ergebnisse in einem Paket zurückgeben, einem sogenannten Tupel. Unsere Funktion kennzahlen liefert so Quote und Anteil auf einmal.</a:t>
             </a:r>
           </a:p>
           <a:p/>
@@ -3848,31 +3848,31 @@
           <a:p/>
           <a:p>
             <a:r>
-              <a:t>Erstens sind Funktionen in Python Objekte. Man kann sie deshalb in eine Liste packen. Genau so bereinigen wir die Werte aus Tabelle 4: Leerzeichen entfernen, Prozentzeichen entfernen, in eine Zahl umwandeln. Das ist dasselbe Muster wie McKinneys clean_strings.</a:t>
+              <a:t>Erstens kann man Funktionen wie normale Werte behandeln, zum Beispiel in eine Liste packen. Das ist wie eine Checkliste mit Arbeitsschritten: Leerzeichen entfernen, Prozentzeichen entfernen, in eine Zahl umwandeln. Jeder Wert aus Tabelle 4 läuft einmal durch diese Liste.</a:t>
             </a:r>
           </a:p>
           <a:p/>
           <a:p>
             <a:r>
-              <a:t>Zweitens Lambda-Funktionen: anonyme Einzeiler. Wir übergeben sie zum Beispiel, um Achsen in Prozent zu beschriften.</a:t>
+              <a:t>Zweitens Lambda-Funktionen: kleine Funktionen ohne Namen, die nur eine Zeile lang sind. Wir brauchen sie zum Beispiel, damit an den Achsen «40 %» statt «0.4» steht.</a:t>
             </a:r>
           </a:p>
           <a:p/>
           <a:p>
             <a:r>
-              <a:t>Drittens Currying mit partial: Aus der allgemeinen Funktion bedingte_quote machen wir quote_frauen, indem wir das Geschlecht fest einsetzen. Das Ergebnis ist P von Z gegeben W.</a:t>
+              <a:t>Drittens partial, bei McKinney Currying genannt: Man legt ein Argument fest und erhält eine neue, speziellere Funktion. Aus der allgemeinen Funktion bedingte_quote wird so quote_frauen, die immer nur die Zulassungsquote der Frauen berechnet.</a:t>
             </a:r>
           </a:p>
           <a:p/>
           <a:p>
             <a:r>
-              <a:t>Viertens ein Generator mit yield: Er liefert die Ergebnisse Fachbereich für Fachbereich, und zwar erst dann, wenn sie gebraucht werden.</a:t>
+              <a:t>Viertens ein Generator mit yield: Er arbeitet wie ein Kellner, der Gang für Gang bringt statt alles auf einmal. Bei uns liefert er die Ergebnisse Fachbereich für Fachbereich.</a:t>
             </a:r>
           </a:p>
           <a:p/>
           <a:p>
             <a:r>
-              <a:t>Und fünftens die Fehlerbehandlung: Wir fangen nur den ValueError ab. Ein Tippfehler in der Tabelle bricht dann mit einer klaren Meldung ab, statt dass wir unbemerkt mit einer falschen Zahl weiterrechnen.</a:t>
+              <a:t>Und fünftens die Fehlerbehandlung: Steht in der Tabelle aus Versehen etwas, das keine Zahl ist, bekommen wir eine klare Fehlermeldung, statt unbemerkt mit einem falschen Wert weiterzurechnen.</a:t>
             </a:r>
           </a:p>
           <a:p/>
@@ -4080,13 +4080,13 @@
           <a:p/>
           <a:p>
             <a:r>
-              <a:t>Schritt 3 ist der wichtigste: Für die stochastische Unabhängigkeit brauchen wir Anzahlen, zum Beispiel wie viele Frauen es insgesamt waren. Aus den gerundeten Prozenten lassen sie sich nicht exakt zurückrechnen. Wir übernehmen sie deshalb aus dem Originaldatensatz, der in R als UCBAdmissions verfügbar ist. Der Code prüft, dass diese Anzahlen alle 24 Prozentwerte der Tabelle ergeben. Das Ergebnis sind null Abweichungen.</a:t>
+              <a:t>Schritt 3 ist der wichtigste. Prozente sagen nur «wie viel von», aber nicht «wie viele». Für Teil c brauchen wir aber Anzahlen, zum Beispiel wie viele Frauen sich insgesamt beworben haben. Wir übernehmen sie deshalb aus dem Originaldatensatz, der in R als UCBAdmissions frei verfügbar ist. Zur Sicherheit prüft unser Code, dass diese Anzahlen genau die 24 Prozentwerte aus Tabelle 4 ergeben. Ergebnis: keine einzige Abweichung.</a:t>
             </a:r>
           </a:p>
           <a:p/>
           <a:p>
             <a:r>
-              <a:t>Schritt 4: Die Daten liegen als eine lange Tabelle vor, mit einer Zeile pro Fachbereich, Geschlecht und Entscheid. Daraus bildet die Funktion kreuztabelle jede Tabelle, die wir brauchen.</a:t>
+              <a:t>Schritt 4: Wir speichern die Daten als eine lange Liste, eine Zeile pro Fachbereich, Geschlecht und Entscheid. Daraus kann die Funktion kreuztabelle jede Tabelle bauen, die wir brauchen.</a:t>
             </a:r>
           </a:p>
           <a:p/>
@@ -4098,7 +4098,7 @@
           <a:p/>
           <a:p>
             <a:r>
-              <a:t>Unten stehen die Libraries und warum wir sie gewählt haben. pandas ist das Standardwerkzeug für Tabellen, eine Kreuztabelle entsteht damit in einer Zeile. numpy rechnet auf ganzen Spalten ohne Schleifen. matplotlib gibt uns volle Kontrolle über Farben und Beschriftungen. re und functools stammen aus der Standardbibliothek. Alle diese Libraries sind in Anaconda enthalten, das wir im Kurs verwenden.</a:t>
+              <a:t>Unten stehen die Libraries, also fertige Werkzeugkästen, und warum wir sie gewählt haben. pandas ist wie Excel in Python: Tabellen filtern und zusammenfassen geht in einer Zeile. numpy rechnet mit ganzen Spalten auf einmal. matplotlib zeichnet die Diagramme, und wir können Farben und Beschriftungen genau festlegen. re und functools sind bereits in Python eingebaut. Alle diese Libraries sind in Anaconda enthalten, das wir im Kurs verwenden.</a:t>
             </a:r>
           </a:p>
           <a:p/>

</xml_diff>